<commit_message>
Retract 'blocking beats single-image' claim; add self-refutation appendix A3b
The T4>S comparison was a calibration shift, not an accuracy gain: yes-rate falls
monotonically with blocking (0.420 -> 0.402 -> 0.367), so all gt=No cells rise and
all gt=Yes cells fall; overall accuracy is unchanged (0.840 vs 0.842). The brief had
pre-registered that S is layout-incomparable and reference-only — we violated that.

Core claim unaffected and strengthened: M -> T4 is a same-layout comparison, and the
leaked cell gains +20.0pp while the same-gt uncontaminated control falls -2.0pp — a
threshold shift would move both up, and a 3.8pp yes-rate shift cannot produce 20pp.

Co-Authored-By: Claude Fable 5 <noreply@anthropic.com>
</commit_message>
<xml_diff>
--- a/meeting/SourceDepth_Phase0_meeting.pptx
+++ b/meeting/SourceDepth_Phase0_meeting.pptx
@@ -27,9 +27,10 @@
     <p:sldId id="275" r:id="rId21"/>
     <p:sldId id="276" r:id="rId22"/>
     <p:sldId id="277" r:id="rId23"/>
+    <p:sldId id="278" r:id="rId24"/>
   </p:sldIdLst>
   <p:notesMasterIdLst>
-    <p:notesMasterId r:id="rId24"/>
+    <p:notesMasterId r:id="rId25"/>
   </p:notesMasterIdLst>
   <p:sldSz cx="12192000" cy="6858000"/>
   <p:notesSz cx="6858000" cy="12192000"/>
@@ -1779,6 +1780,94 @@
             <a:fld id="{F7021451-1387-4CA6-816F-3879F97B5CBC}" type="slidenum">
               <a:rPr lang="en-US"/>
               <a:t>22</a:t>
+            </a:fld>
+            <a:endParaRPr lang="en-US"/>
+          </a:p>
+        </p:txBody>
+      </p:sp>
+    </p:spTree>
+    <p:extLst>
+      <p:ext uri="{BB962C8B-B14F-4D97-AF65-F5344CB8AC3E}">
+        <p14:creationId xmlns:p14="http://schemas.microsoft.com/office/powerpoint/2010/main" val="1024086991"/>
+      </p:ext>
+    </p:extLst>
+  </p:cSld>
+  <p:clrMapOvr>
+    <a:masterClrMapping/>
+  </p:clrMapOvr>
+</p:notes>
+</file>
+
+<file path=ppt/notesSlides/notesSlide23.xml><?xml version="1.0" encoding="utf-8"?>
+<p:notes xmlns:a="http://schemas.openxmlformats.org/drawingml/2006/main" xmlns:r="http://schemas.openxmlformats.org/officeDocument/2006/relationships" xmlns:p="http://schemas.openxmlformats.org/presentationml/2006/main">
+  <p:cSld>
+    <p:spTree>
+      <p:nvGrpSpPr>
+        <p:cNvPr id="1" name=""/>
+        <p:cNvGrpSpPr/>
+        <p:nvPr/>
+      </p:nvGrpSpPr>
+      <p:grpSpPr>
+        <a:xfrm>
+          <a:off x="0" y="0"/>
+          <a:ext cx="0" cy="0"/>
+          <a:chOff x="0" y="0"/>
+          <a:chExt cx="0" cy="0"/>
+        </a:xfrm>
+      </p:grpSpPr>
+      <p:sp>
+        <p:nvSpPr>
+          <p:cNvPr id="2" name="Slide Image Placeholder 1"/>
+          <p:cNvSpPr>
+            <a:spLocks noGrp="1" noRot="1" noChangeAspect="1"/>
+          </p:cNvSpPr>
+          <p:nvPr>
+            <p:ph type="sldImg"/>
+          </p:nvPr>
+        </p:nvSpPr>
+        <p:spPr/>
+      </p:sp>
+      <p:sp>
+        <p:nvSpPr>
+          <p:cNvPr id="3" name="Notes Placeholder 2"/>
+          <p:cNvSpPr>
+            <a:spLocks noGrp="1"/>
+          </p:cNvSpPr>
+          <p:nvPr>
+            <p:ph type="body" idx="1"/>
+          </p:nvPr>
+        </p:nvSpPr>
+        <p:spPr/>
+        <p:txBody>
+          <a:bodyPr/>
+          <a:lstStyle/>
+          <a:p>
+            <a:r>
+              <a:rPr lang="en-US" dirty="0"/>
+              <a:t/>
+            </a:r>
+            <a:endParaRPr lang="en-US" dirty="0"/>
+          </a:p>
+        </p:txBody>
+      </p:sp>
+      <p:sp>
+        <p:nvSpPr>
+          <p:cNvPr id="4" name="Slide Number Placeholder 3"/>
+          <p:cNvSpPr>
+            <a:spLocks noGrp="1"/>
+          </p:cNvSpPr>
+          <p:nvPr>
+            <p:ph type="sldNum" sz="quarter" idx="10"/>
+          </p:nvPr>
+        </p:nvSpPr>
+        <p:spPr/>
+        <p:txBody>
+          <a:bodyPr/>
+          <a:lstStyle/>
+          <a:p>
+            <a:fld id="{F7021451-1387-4CA6-816F-3879F97B5CBC}" type="slidenum">
+              <a:rPr lang="en-US"/>
+              <a:t>23</a:t>
             </a:fld>
             <a:endParaRPr lang="en-US"/>
           </a:p>
@@ -6950,6 +7039,26 @@
                 <a:ea typeface="Arial" pitchFamily="34" charset="-122"/>
                 <a:cs typeface="Arial" pitchFamily="34" charset="-120"/>
               </a:rPr>
+              <a:t>A3b 자체 반증 점검 (단일 이미지 비교)</a:t>
+            </a:r>
+            <a:endParaRPr lang="en-US" sz="1350" dirty="0"/>
+          </a:p>
+          <a:p>
+            <a:pPr indent="0" marL="0">
+              <a:spcAft>
+                <a:spcPts val="900"/>
+              </a:spcAft>
+              <a:buNone/>
+            </a:pPr>
+            <a:r>
+              <a:rPr lang="en-US" sz="1350" dirty="0">
+                <a:solidFill>
+                  <a:srgbClr val="D7E4EF"/>
+                </a:solidFill>
+                <a:latin typeface="Arial" pitchFamily="34" charset="0"/>
+                <a:ea typeface="Arial" pitchFamily="34" charset="-122"/>
+                <a:cs typeface="Arial" pitchFamily="34" charset="-120"/>
+              </a:rPr>
               <a:t>A4  층별 식별률 전체 곡선</a:t>
             </a:r>
             <a:endParaRPr lang="en-US" sz="1350" dirty="0"/>
@@ -17975,7 +18084,7 @@
                 <a:ea typeface="Arial" pitchFamily="34" charset="-122"/>
                 <a:cs typeface="Arial" pitchFamily="34" charset="-120"/>
               </a:rPr>
-              <a:t>APPENDIX A4</a:t>
+              <a:t>APPENDIX A3b</a:t>
             </a:r>
             <a:endParaRPr lang="en-US" sz="1150" dirty="0"/>
           </a:p>
@@ -18014,36 +18123,2521 @@
                 <a:ea typeface="Arial" pitchFamily="34" charset="-122"/>
                 <a:cs typeface="Arial" pitchFamily="34" charset="-120"/>
               </a:rPr>
-              <a:t>층별 '관련 이미지' 식별률 — 16개 신호 평균 기준 (n=600)</a:t>
+              <a:t>자체 반증 점검 — "차단이 이미지 1장보다 낫다"는 주장은 성립하지 않는다</a:t>
             </a:r>
             <a:endParaRPr lang="en-US" sz="2200" dirty="0"/>
           </a:p>
         </p:txBody>
       </p:sp>
-      <p:pic>
-        <p:nvPicPr>
-          <p:cNvPr id="4" name="Image 0" descr="/Users/hansangmin/Source-Depth/results/aux_chartA_ident_by_layer.png">    </p:cNvPr>
-          <p:cNvPicPr>
-            <a:picLocks noChangeAspect="1"/>
-          </p:cNvPicPr>
-          <p:nvPr/>
-        </p:nvPicPr>
-        <p:blipFill>
-          <a:blip r:embed="rId1"/>
-          <a:stretch>
-            <a:fillRect/>
-          </a:stretch>
-        </p:blipFill>
-        <p:spPr>
-          <a:xfrm>
-            <a:off x="685800" y="1737360"/>
-            <a:ext cx="10789920" cy="3922776"/>
-          </a:xfrm>
-          <a:prstGeom prst="rect">
-            <a:avLst/>
-          </a:prstGeom>
-        </p:spPr>
-      </p:pic>
+      <p:graphicFrame>
+        <p:nvGraphicFramePr>
+          <p:cNvPr id="20" name="Table 0"/>
+          <p:cNvGraphicFramePr>
+            <a:graphicFrameLocks noGrp="1"/>
+          </p:cNvGraphicFramePr>
+          <p:nvPr>
+            <p:extLst>
+              <p:ext uri="{D42A27DB-BD31-4B8C-83A1-F6EECF244321}">
+                <p14:modId xmlns:p14="http://schemas.microsoft.com/office/powerpoint/2010/main" val="1579011935"/>
+              </p:ext>
+            </p:extLst>
+          </p:nvPr>
+        </p:nvGraphicFramePr>
+        <p:xfrm>
+          <a:off x="502920" y="1600200"/>
+          <a:ext cx="11201400" cy="914400"/>
+        </p:xfrm>
+        <a:graphic>
+          <a:graphicData uri="http://schemas.openxmlformats.org/drawingml/2006/table">
+            <a:tbl>
+              <a:tblPr/>
+              <a:tblGrid>
+                <a:gridCol w="1600200"/>
+                <a:gridCol w="1600200"/>
+                <a:gridCol w="1600200"/>
+                <a:gridCol w="1600200"/>
+                <a:gridCol w="1600200"/>
+                <a:gridCol w="1600200"/>
+                <a:gridCol w="1600200"/>
+              </a:tblGrid>
+              <a:tr h="566928">
+                <a:tc>
+                  <a:txBody>
+                    <a:bodyPr/>
+                    <a:lstStyle/>
+                    <a:p>
+                      <a:pPr algn="ctr" indent="0" marL="0">
+                        <a:buNone/>
+                      </a:pPr>
+                      <a:r>
+                        <a:rPr lang="en-US" sz="1100" b="1" dirty="0">
+                          <a:solidFill>
+                            <a:srgbClr val="FFFFFF"/>
+                          </a:solidFill>
+                          <a:latin typeface="Arial" pitchFamily="34" charset="0"/>
+                          <a:ea typeface="Arial" pitchFamily="34" charset="-122"/>
+                          <a:cs typeface="Arial" pitchFamily="34" charset="-120"/>
+                        </a:rPr>
+                        <a:t>조건</a:t>
+                      </a:r>
+                      <a:endParaRPr lang="en-US" sz="1100" dirty="0">
+                        <a:latin typeface="Arial" charset="0"/>
+                        <a:ea typeface="Arial" charset="0"/>
+                        <a:cs typeface="Arial" charset="0"/>
+                      </a:endParaRPr>
+                    </a:p>
+                  </a:txBody>
+                  <a:tcPr marL="91440" marR="91440" marT="45720" marB="45720" anchor="ctr">
+                    <a:lnL w="9525" cap="flat" cmpd="sng" algn="ctr">
+                      <a:solidFill>
+                        <a:srgbClr val="E2E8F0"/>
+                      </a:solidFill>
+                      <a:prstDash val="solid"/>
+                      <a:round/>
+                      <a:headEnd type="none" w="med" len="med"/>
+                      <a:tailEnd type="none" w="med" len="med"/>
+                    </a:lnL>
+                    <a:lnR w="9525" cap="flat" cmpd="sng" algn="ctr">
+                      <a:solidFill>
+                        <a:srgbClr val="E2E8F0"/>
+                      </a:solidFill>
+                      <a:prstDash val="solid"/>
+                      <a:round/>
+                      <a:headEnd type="none" w="med" len="med"/>
+                      <a:tailEnd type="none" w="med" len="med"/>
+                    </a:lnR>
+                    <a:lnT w="9525" cap="flat" cmpd="sng" algn="ctr">
+                      <a:solidFill>
+                        <a:srgbClr val="E2E8F0"/>
+                      </a:solidFill>
+                      <a:prstDash val="solid"/>
+                      <a:round/>
+                      <a:headEnd type="none" w="med" len="med"/>
+                      <a:tailEnd type="none" w="med" len="med"/>
+                    </a:lnT>
+                    <a:lnB w="9525" cap="flat" cmpd="sng" algn="ctr">
+                      <a:solidFill>
+                        <a:srgbClr val="E2E8F0"/>
+                      </a:solidFill>
+                      <a:prstDash val="solid"/>
+                      <a:round/>
+                      <a:headEnd type="none" w="med" len="med"/>
+                      <a:tailEnd type="none" w="med" len="med"/>
+                    </a:lnB>
+                    <a:solidFill>
+                      <a:srgbClr val="1F3B57"/>
+                    </a:solidFill>
+                  </a:tcPr>
+                </a:tc>
+                <a:tc>
+                  <a:txBody>
+                    <a:bodyPr/>
+                    <a:lstStyle/>
+                    <a:p>
+                      <a:pPr algn="ctr" indent="0" marL="0">
+                        <a:buNone/>
+                      </a:pPr>
+                      <a:r>
+                        <a:rPr lang="en-US" sz="1100" b="1" dirty="0">
+                          <a:solidFill>
+                            <a:srgbClr val="FFFFFF"/>
+                          </a:solidFill>
+                          <a:latin typeface="Arial" pitchFamily="34" charset="0"/>
+                          <a:ea typeface="Arial" pitchFamily="34" charset="-122"/>
+                          <a:cs typeface="Arial" pitchFamily="34" charset="-120"/>
+                        </a:rPr>
+                        <a:t>정답 '없다'</a:t>
+                      </a:r>
+                      <a:endParaRPr lang="en-US" sz="1100" dirty="0">
+                        <a:latin typeface="Arial" charset="0"/>
+                        <a:ea typeface="Arial" charset="0"/>
+                        <a:cs typeface="Arial" charset="0"/>
+                      </a:endParaRPr>
+                    </a:p>
+                    <a:p>
+                      <a:pPr algn="ctr" indent="0" marL="0">
+                        <a:buNone/>
+                      </a:pPr>
+                      <a:r>
+                        <a:rPr lang="en-US" sz="1100" b="1" dirty="0">
+                          <a:solidFill>
+                            <a:srgbClr val="FFFFFF"/>
+                          </a:solidFill>
+                          <a:latin typeface="Arial" pitchFamily="34" charset="0"/>
+                          <a:ea typeface="Arial" pitchFamily="34" charset="-122"/>
+                          <a:cs typeface="Arial" pitchFamily="34" charset="-120"/>
+                        </a:rPr>
+                        <a:t>셀1</a:t>
+                      </a:r>
+                      <a:endParaRPr lang="en-US" sz="1100" dirty="0">
+                        <a:latin typeface="Arial" charset="0"/>
+                        <a:ea typeface="Arial" charset="0"/>
+                        <a:cs typeface="Arial" charset="0"/>
+                      </a:endParaRPr>
+                    </a:p>
+                  </a:txBody>
+                  <a:tcPr marL="91440" marR="91440" marT="45720" marB="45720" anchor="ctr">
+                    <a:lnL w="9525" cap="flat" cmpd="sng" algn="ctr">
+                      <a:solidFill>
+                        <a:srgbClr val="E2E8F0"/>
+                      </a:solidFill>
+                      <a:prstDash val="solid"/>
+                      <a:round/>
+                      <a:headEnd type="none" w="med" len="med"/>
+                      <a:tailEnd type="none" w="med" len="med"/>
+                    </a:lnL>
+                    <a:lnR w="9525" cap="flat" cmpd="sng" algn="ctr">
+                      <a:solidFill>
+                        <a:srgbClr val="E2E8F0"/>
+                      </a:solidFill>
+                      <a:prstDash val="solid"/>
+                      <a:round/>
+                      <a:headEnd type="none" w="med" len="med"/>
+                      <a:tailEnd type="none" w="med" len="med"/>
+                    </a:lnR>
+                    <a:lnT w="9525" cap="flat" cmpd="sng" algn="ctr">
+                      <a:solidFill>
+                        <a:srgbClr val="E2E8F0"/>
+                      </a:solidFill>
+                      <a:prstDash val="solid"/>
+                      <a:round/>
+                      <a:headEnd type="none" w="med" len="med"/>
+                      <a:tailEnd type="none" w="med" len="med"/>
+                    </a:lnT>
+                    <a:lnB w="9525" cap="flat" cmpd="sng" algn="ctr">
+                      <a:solidFill>
+                        <a:srgbClr val="E2E8F0"/>
+                      </a:solidFill>
+                      <a:prstDash val="solid"/>
+                      <a:round/>
+                      <a:headEnd type="none" w="med" len="med"/>
+                      <a:tailEnd type="none" w="med" len="med"/>
+                    </a:lnB>
+                    <a:solidFill>
+                      <a:srgbClr val="1F3B57"/>
+                    </a:solidFill>
+                  </a:tcPr>
+                </a:tc>
+                <a:tc>
+                  <a:txBody>
+                    <a:bodyPr/>
+                    <a:lstStyle/>
+                    <a:p>
+                      <a:pPr algn="ctr" indent="0" marL="0">
+                        <a:buNone/>
+                      </a:pPr>
+                      <a:r>
+                        <a:rPr lang="en-US" sz="1100" b="1" dirty="0">
+                          <a:solidFill>
+                            <a:srgbClr val="FFFFFF"/>
+                          </a:solidFill>
+                          <a:latin typeface="Arial" pitchFamily="34" charset="0"/>
+                          <a:ea typeface="Arial" pitchFamily="34" charset="-122"/>
+                          <a:cs typeface="Arial" pitchFamily="34" charset="-120"/>
+                        </a:rPr>
+                        <a:t>정답 '없다'</a:t>
+                      </a:r>
+                      <a:endParaRPr lang="en-US" sz="1100" dirty="0">
+                        <a:latin typeface="Arial" charset="0"/>
+                        <a:ea typeface="Arial" charset="0"/>
+                        <a:cs typeface="Arial" charset="0"/>
+                      </a:endParaRPr>
+                    </a:p>
+                    <a:p>
+                      <a:pPr algn="ctr" indent="0" marL="0">
+                        <a:buNone/>
+                      </a:pPr>
+                      <a:r>
+                        <a:rPr lang="en-US" sz="1100" b="1" dirty="0">
+                          <a:solidFill>
+                            <a:srgbClr val="FFFFFF"/>
+                          </a:solidFill>
+                          <a:latin typeface="Arial" pitchFamily="34" charset="0"/>
+                          <a:ea typeface="Arial" pitchFamily="34" charset="-122"/>
+                          <a:cs typeface="Arial" pitchFamily="34" charset="-120"/>
+                        </a:rPr>
+                        <a:t>셀3</a:t>
+                      </a:r>
+                      <a:endParaRPr lang="en-US" sz="1100" dirty="0">
+                        <a:latin typeface="Arial" charset="0"/>
+                        <a:ea typeface="Arial" charset="0"/>
+                        <a:cs typeface="Arial" charset="0"/>
+                      </a:endParaRPr>
+                    </a:p>
+                  </a:txBody>
+                  <a:tcPr marL="91440" marR="91440" marT="45720" marB="45720" anchor="ctr">
+                    <a:lnL w="9525" cap="flat" cmpd="sng" algn="ctr">
+                      <a:solidFill>
+                        <a:srgbClr val="E2E8F0"/>
+                      </a:solidFill>
+                      <a:prstDash val="solid"/>
+                      <a:round/>
+                      <a:headEnd type="none" w="med" len="med"/>
+                      <a:tailEnd type="none" w="med" len="med"/>
+                    </a:lnL>
+                    <a:lnR w="9525" cap="flat" cmpd="sng" algn="ctr">
+                      <a:solidFill>
+                        <a:srgbClr val="E2E8F0"/>
+                      </a:solidFill>
+                      <a:prstDash val="solid"/>
+                      <a:round/>
+                      <a:headEnd type="none" w="med" len="med"/>
+                      <a:tailEnd type="none" w="med" len="med"/>
+                    </a:lnR>
+                    <a:lnT w="9525" cap="flat" cmpd="sng" algn="ctr">
+                      <a:solidFill>
+                        <a:srgbClr val="E2E8F0"/>
+                      </a:solidFill>
+                      <a:prstDash val="solid"/>
+                      <a:round/>
+                      <a:headEnd type="none" w="med" len="med"/>
+                      <a:tailEnd type="none" w="med" len="med"/>
+                    </a:lnT>
+                    <a:lnB w="9525" cap="flat" cmpd="sng" algn="ctr">
+                      <a:solidFill>
+                        <a:srgbClr val="E2E8F0"/>
+                      </a:solidFill>
+                      <a:prstDash val="solid"/>
+                      <a:round/>
+                      <a:headEnd type="none" w="med" len="med"/>
+                      <a:tailEnd type="none" w="med" len="med"/>
+                    </a:lnB>
+                    <a:solidFill>
+                      <a:srgbClr val="1F3B57"/>
+                    </a:solidFill>
+                  </a:tcPr>
+                </a:tc>
+                <a:tc>
+                  <a:txBody>
+                    <a:bodyPr/>
+                    <a:lstStyle/>
+                    <a:p>
+                      <a:pPr algn="ctr" indent="0" marL="0">
+                        <a:buNone/>
+                      </a:pPr>
+                      <a:r>
+                        <a:rPr lang="en-US" sz="1100" b="1" dirty="0">
+                          <a:solidFill>
+                            <a:srgbClr val="FFFFFF"/>
+                          </a:solidFill>
+                          <a:latin typeface="Arial" pitchFamily="34" charset="0"/>
+                          <a:ea typeface="Arial" pitchFamily="34" charset="-122"/>
+                          <a:cs typeface="Arial" pitchFamily="34" charset="-120"/>
+                        </a:rPr>
+                        <a:t>정답 '있다'</a:t>
+                      </a:r>
+                      <a:endParaRPr lang="en-US" sz="1100" dirty="0">
+                        <a:latin typeface="Arial" charset="0"/>
+                        <a:ea typeface="Arial" charset="0"/>
+                        <a:cs typeface="Arial" charset="0"/>
+                      </a:endParaRPr>
+                    </a:p>
+                    <a:p>
+                      <a:pPr algn="ctr" indent="0" marL="0">
+                        <a:buNone/>
+                      </a:pPr>
+                      <a:r>
+                        <a:rPr lang="en-US" sz="1100" b="1" dirty="0">
+                          <a:solidFill>
+                            <a:srgbClr val="FFFFFF"/>
+                          </a:solidFill>
+                          <a:latin typeface="Arial" pitchFamily="34" charset="0"/>
+                          <a:ea typeface="Arial" pitchFamily="34" charset="-122"/>
+                          <a:cs typeface="Arial" pitchFamily="34" charset="-120"/>
+                        </a:rPr>
+                        <a:t>셀2</a:t>
+                      </a:r>
+                      <a:endParaRPr lang="en-US" sz="1100" dirty="0">
+                        <a:latin typeface="Arial" charset="0"/>
+                        <a:ea typeface="Arial" charset="0"/>
+                        <a:cs typeface="Arial" charset="0"/>
+                      </a:endParaRPr>
+                    </a:p>
+                  </a:txBody>
+                  <a:tcPr marL="91440" marR="91440" marT="45720" marB="45720" anchor="ctr">
+                    <a:lnL w="9525" cap="flat" cmpd="sng" algn="ctr">
+                      <a:solidFill>
+                        <a:srgbClr val="E2E8F0"/>
+                      </a:solidFill>
+                      <a:prstDash val="solid"/>
+                      <a:round/>
+                      <a:headEnd type="none" w="med" len="med"/>
+                      <a:tailEnd type="none" w="med" len="med"/>
+                    </a:lnL>
+                    <a:lnR w="9525" cap="flat" cmpd="sng" algn="ctr">
+                      <a:solidFill>
+                        <a:srgbClr val="E2E8F0"/>
+                      </a:solidFill>
+                      <a:prstDash val="solid"/>
+                      <a:round/>
+                      <a:headEnd type="none" w="med" len="med"/>
+                      <a:tailEnd type="none" w="med" len="med"/>
+                    </a:lnR>
+                    <a:lnT w="9525" cap="flat" cmpd="sng" algn="ctr">
+                      <a:solidFill>
+                        <a:srgbClr val="E2E8F0"/>
+                      </a:solidFill>
+                      <a:prstDash val="solid"/>
+                      <a:round/>
+                      <a:headEnd type="none" w="med" len="med"/>
+                      <a:tailEnd type="none" w="med" len="med"/>
+                    </a:lnT>
+                    <a:lnB w="9525" cap="flat" cmpd="sng" algn="ctr">
+                      <a:solidFill>
+                        <a:srgbClr val="E2E8F0"/>
+                      </a:solidFill>
+                      <a:prstDash val="solid"/>
+                      <a:round/>
+                      <a:headEnd type="none" w="med" len="med"/>
+                      <a:tailEnd type="none" w="med" len="med"/>
+                    </a:lnB>
+                    <a:solidFill>
+                      <a:srgbClr val="1F3B57"/>
+                    </a:solidFill>
+                  </a:tcPr>
+                </a:tc>
+                <a:tc>
+                  <a:txBody>
+                    <a:bodyPr/>
+                    <a:lstStyle/>
+                    <a:p>
+                      <a:pPr algn="ctr" indent="0" marL="0">
+                        <a:buNone/>
+                      </a:pPr>
+                      <a:r>
+                        <a:rPr lang="en-US" sz="1100" b="1" dirty="0">
+                          <a:solidFill>
+                            <a:srgbClr val="FFFFFF"/>
+                          </a:solidFill>
+                          <a:latin typeface="Arial" pitchFamily="34" charset="0"/>
+                          <a:ea typeface="Arial" pitchFamily="34" charset="-122"/>
+                          <a:cs typeface="Arial" pitchFamily="34" charset="-120"/>
+                        </a:rPr>
+                        <a:t>정답 '있다'</a:t>
+                      </a:r>
+                      <a:endParaRPr lang="en-US" sz="1100" dirty="0">
+                        <a:latin typeface="Arial" charset="0"/>
+                        <a:ea typeface="Arial" charset="0"/>
+                        <a:cs typeface="Arial" charset="0"/>
+                      </a:endParaRPr>
+                    </a:p>
+                    <a:p>
+                      <a:pPr algn="ctr" indent="0" marL="0">
+                        <a:buNone/>
+                      </a:pPr>
+                      <a:r>
+                        <a:rPr lang="en-US" sz="1100" b="1" dirty="0">
+                          <a:solidFill>
+                            <a:srgbClr val="FFFFFF"/>
+                          </a:solidFill>
+                          <a:latin typeface="Arial" pitchFamily="34" charset="0"/>
+                          <a:ea typeface="Arial" pitchFamily="34" charset="-122"/>
+                          <a:cs typeface="Arial" pitchFamily="34" charset="-120"/>
+                        </a:rPr>
+                        <a:t>셀4</a:t>
+                      </a:r>
+                      <a:endParaRPr lang="en-US" sz="1100" dirty="0">
+                        <a:latin typeface="Arial" charset="0"/>
+                        <a:ea typeface="Arial" charset="0"/>
+                        <a:cs typeface="Arial" charset="0"/>
+                      </a:endParaRPr>
+                    </a:p>
+                  </a:txBody>
+                  <a:tcPr marL="91440" marR="91440" marT="45720" marB="45720" anchor="ctr">
+                    <a:lnL w="9525" cap="flat" cmpd="sng" algn="ctr">
+                      <a:solidFill>
+                        <a:srgbClr val="E2E8F0"/>
+                      </a:solidFill>
+                      <a:prstDash val="solid"/>
+                      <a:round/>
+                      <a:headEnd type="none" w="med" len="med"/>
+                      <a:tailEnd type="none" w="med" len="med"/>
+                    </a:lnL>
+                    <a:lnR w="9525" cap="flat" cmpd="sng" algn="ctr">
+                      <a:solidFill>
+                        <a:srgbClr val="E2E8F0"/>
+                      </a:solidFill>
+                      <a:prstDash val="solid"/>
+                      <a:round/>
+                      <a:headEnd type="none" w="med" len="med"/>
+                      <a:tailEnd type="none" w="med" len="med"/>
+                    </a:lnR>
+                    <a:lnT w="9525" cap="flat" cmpd="sng" algn="ctr">
+                      <a:solidFill>
+                        <a:srgbClr val="E2E8F0"/>
+                      </a:solidFill>
+                      <a:prstDash val="solid"/>
+                      <a:round/>
+                      <a:headEnd type="none" w="med" len="med"/>
+                      <a:tailEnd type="none" w="med" len="med"/>
+                    </a:lnT>
+                    <a:lnB w="9525" cap="flat" cmpd="sng" algn="ctr">
+                      <a:solidFill>
+                        <a:srgbClr val="E2E8F0"/>
+                      </a:solidFill>
+                      <a:prstDash val="solid"/>
+                      <a:round/>
+                      <a:headEnd type="none" w="med" len="med"/>
+                      <a:tailEnd type="none" w="med" len="med"/>
+                    </a:lnB>
+                    <a:solidFill>
+                      <a:srgbClr val="1F3B57"/>
+                    </a:solidFill>
+                  </a:tcPr>
+                </a:tc>
+                <a:tc>
+                  <a:txBody>
+                    <a:bodyPr/>
+                    <a:lstStyle/>
+                    <a:p>
+                      <a:pPr algn="ctr" indent="0" marL="0">
+                        <a:buNone/>
+                      </a:pPr>
+                      <a:r>
+                        <a:rPr lang="en-US" sz="1100" b="1" dirty="0">
+                          <a:solidFill>
+                            <a:srgbClr val="FFFFFF"/>
+                          </a:solidFill>
+                          <a:latin typeface="Arial" pitchFamily="34" charset="0"/>
+                          <a:ea typeface="Arial" pitchFamily="34" charset="-122"/>
+                          <a:cs typeface="Arial" pitchFamily="34" charset="-120"/>
+                        </a:rPr>
+                        <a:t>전체</a:t>
+                      </a:r>
+                      <a:endParaRPr lang="en-US" sz="1100" dirty="0">
+                        <a:latin typeface="Arial" charset="0"/>
+                        <a:ea typeface="Arial" charset="0"/>
+                        <a:cs typeface="Arial" charset="0"/>
+                      </a:endParaRPr>
+                    </a:p>
+                  </a:txBody>
+                  <a:tcPr marL="91440" marR="91440" marT="45720" marB="45720" anchor="ctr">
+                    <a:lnL w="9525" cap="flat" cmpd="sng" algn="ctr">
+                      <a:solidFill>
+                        <a:srgbClr val="E2E8F0"/>
+                      </a:solidFill>
+                      <a:prstDash val="solid"/>
+                      <a:round/>
+                      <a:headEnd type="none" w="med" len="med"/>
+                      <a:tailEnd type="none" w="med" len="med"/>
+                    </a:lnL>
+                    <a:lnR w="9525" cap="flat" cmpd="sng" algn="ctr">
+                      <a:solidFill>
+                        <a:srgbClr val="E2E8F0"/>
+                      </a:solidFill>
+                      <a:prstDash val="solid"/>
+                      <a:round/>
+                      <a:headEnd type="none" w="med" len="med"/>
+                      <a:tailEnd type="none" w="med" len="med"/>
+                    </a:lnR>
+                    <a:lnT w="9525" cap="flat" cmpd="sng" algn="ctr">
+                      <a:solidFill>
+                        <a:srgbClr val="E2E8F0"/>
+                      </a:solidFill>
+                      <a:prstDash val="solid"/>
+                      <a:round/>
+                      <a:headEnd type="none" w="med" len="med"/>
+                      <a:tailEnd type="none" w="med" len="med"/>
+                    </a:lnT>
+                    <a:lnB w="9525" cap="flat" cmpd="sng" algn="ctr">
+                      <a:solidFill>
+                        <a:srgbClr val="E2E8F0"/>
+                      </a:solidFill>
+                      <a:prstDash val="solid"/>
+                      <a:round/>
+                      <a:headEnd type="none" w="med" len="med"/>
+                      <a:tailEnd type="none" w="med" len="med"/>
+                    </a:lnB>
+                    <a:solidFill>
+                      <a:srgbClr val="1F3B57"/>
+                    </a:solidFill>
+                  </a:tcPr>
+                </a:tc>
+                <a:tc>
+                  <a:txBody>
+                    <a:bodyPr/>
+                    <a:lstStyle/>
+                    <a:p>
+                      <a:pPr algn="ctr" indent="0" marL="0">
+                        <a:buNone/>
+                      </a:pPr>
+                      <a:r>
+                        <a:rPr lang="en-US" sz="1100" b="1" dirty="0">
+                          <a:solidFill>
+                            <a:srgbClr val="FFFFFF"/>
+                          </a:solidFill>
+                          <a:latin typeface="Arial" pitchFamily="34" charset="0"/>
+                          <a:ea typeface="Arial" pitchFamily="34" charset="-122"/>
+                          <a:cs typeface="Arial" pitchFamily="34" charset="-120"/>
+                        </a:rPr>
+                        <a:t>'있다' 응답률</a:t>
+                      </a:r>
+                      <a:endParaRPr lang="en-US" sz="1100" dirty="0">
+                        <a:latin typeface="Arial" charset="0"/>
+                        <a:ea typeface="Arial" charset="0"/>
+                        <a:cs typeface="Arial" charset="0"/>
+                      </a:endParaRPr>
+                    </a:p>
+                  </a:txBody>
+                  <a:tcPr marL="91440" marR="91440" marT="45720" marB="45720" anchor="ctr">
+                    <a:lnL w="9525" cap="flat" cmpd="sng" algn="ctr">
+                      <a:solidFill>
+                        <a:srgbClr val="E2E8F0"/>
+                      </a:solidFill>
+                      <a:prstDash val="solid"/>
+                      <a:round/>
+                      <a:headEnd type="none" w="med" len="med"/>
+                      <a:tailEnd type="none" w="med" len="med"/>
+                    </a:lnL>
+                    <a:lnR w="9525" cap="flat" cmpd="sng" algn="ctr">
+                      <a:solidFill>
+                        <a:srgbClr val="E2E8F0"/>
+                      </a:solidFill>
+                      <a:prstDash val="solid"/>
+                      <a:round/>
+                      <a:headEnd type="none" w="med" len="med"/>
+                      <a:tailEnd type="none" w="med" len="med"/>
+                    </a:lnR>
+                    <a:lnT w="9525" cap="flat" cmpd="sng" algn="ctr">
+                      <a:solidFill>
+                        <a:srgbClr val="E2E8F0"/>
+                      </a:solidFill>
+                      <a:prstDash val="solid"/>
+                      <a:round/>
+                      <a:headEnd type="none" w="med" len="med"/>
+                      <a:tailEnd type="none" w="med" len="med"/>
+                    </a:lnT>
+                    <a:lnB w="9525" cap="flat" cmpd="sng" algn="ctr">
+                      <a:solidFill>
+                        <a:srgbClr val="E2E8F0"/>
+                      </a:solidFill>
+                      <a:prstDash val="solid"/>
+                      <a:round/>
+                      <a:headEnd type="none" w="med" len="med"/>
+                      <a:tailEnd type="none" w="med" len="med"/>
+                    </a:lnB>
+                    <a:solidFill>
+                      <a:srgbClr val="1F3B57"/>
+                    </a:solidFill>
+                  </a:tcPr>
+                </a:tc>
+              </a:tr>
+              <a:tr h="402336">
+                <a:tc>
+                  <a:txBody>
+                    <a:bodyPr/>
+                    <a:lstStyle/>
+                    <a:p>
+                      <a:pPr algn="ctr" indent="0" marL="0">
+                        <a:buNone/>
+                      </a:pPr>
+                      <a:r>
+                        <a:rPr lang="en-US" sz="1100" b="1" dirty="0">
+                          <a:solidFill>
+                            <a:srgbClr val="1F3B57"/>
+                          </a:solidFill>
+                          <a:latin typeface="Arial" pitchFamily="34" charset="0"/>
+                          <a:ea typeface="Arial" pitchFamily="34" charset="-122"/>
+                          <a:cs typeface="Arial" pitchFamily="34" charset="-120"/>
+                        </a:rPr>
+                        <a:t>이미지 1장 (S)</a:t>
+                      </a:r>
+                      <a:endParaRPr lang="en-US" sz="1100" dirty="0">
+                        <a:latin typeface="Arial" charset="0"/>
+                        <a:ea typeface="Arial" charset="0"/>
+                        <a:cs typeface="Arial" charset="0"/>
+                      </a:endParaRPr>
+                    </a:p>
+                  </a:txBody>
+                  <a:tcPr marL="91440" marR="91440" marT="45720" marB="45720" anchor="ctr">
+                    <a:lnL w="9525" cap="flat" cmpd="sng" algn="ctr">
+                      <a:solidFill>
+                        <a:srgbClr val="E2E8F0"/>
+                      </a:solidFill>
+                      <a:prstDash val="solid"/>
+                      <a:round/>
+                      <a:headEnd type="none" w="med" len="med"/>
+                      <a:tailEnd type="none" w="med" len="med"/>
+                    </a:lnL>
+                    <a:lnR w="9525" cap="flat" cmpd="sng" algn="ctr">
+                      <a:solidFill>
+                        <a:srgbClr val="E2E8F0"/>
+                      </a:solidFill>
+                      <a:prstDash val="solid"/>
+                      <a:round/>
+                      <a:headEnd type="none" w="med" len="med"/>
+                      <a:tailEnd type="none" w="med" len="med"/>
+                    </a:lnR>
+                    <a:lnT w="9525" cap="flat" cmpd="sng" algn="ctr">
+                      <a:solidFill>
+                        <a:srgbClr val="E2E8F0"/>
+                      </a:solidFill>
+                      <a:prstDash val="solid"/>
+                      <a:round/>
+                      <a:headEnd type="none" w="med" len="med"/>
+                      <a:tailEnd type="none" w="med" len="med"/>
+                    </a:lnT>
+                    <a:lnB w="9525" cap="flat" cmpd="sng" algn="ctr">
+                      <a:solidFill>
+                        <a:srgbClr val="E2E8F0"/>
+                      </a:solidFill>
+                      <a:prstDash val="solid"/>
+                      <a:round/>
+                      <a:headEnd type="none" w="med" len="med"/>
+                      <a:tailEnd type="none" w="med" len="med"/>
+                    </a:lnB>
+                    <a:solidFill>
+                      <a:srgbClr val="FFFFFF"/>
+                    </a:solidFill>
+                  </a:tcPr>
+                </a:tc>
+                <a:tc>
+                  <a:txBody>
+                    <a:bodyPr/>
+                    <a:lstStyle/>
+                    <a:p>
+                      <a:pPr algn="ctr" indent="0" marL="0">
+                        <a:buNone/>
+                      </a:pPr>
+                      <a:r>
+                        <a:rPr lang="en-US" sz="1100" dirty="0">
+                          <a:solidFill>
+                            <a:srgbClr val="1F3B57"/>
+                          </a:solidFill>
+                          <a:latin typeface="Arial" pitchFamily="34" charset="0"/>
+                          <a:ea typeface="Arial" pitchFamily="34" charset="-122"/>
+                          <a:cs typeface="Arial" pitchFamily="34" charset="-120"/>
+                        </a:rPr>
+                        <a:t>0.893</a:t>
+                      </a:r>
+                      <a:endParaRPr lang="en-US" sz="1100" dirty="0">
+                        <a:latin typeface="Arial" charset="0"/>
+                        <a:ea typeface="Arial" charset="0"/>
+                        <a:cs typeface="Arial" charset="0"/>
+                      </a:endParaRPr>
+                    </a:p>
+                  </a:txBody>
+                  <a:tcPr marL="91440" marR="91440" marT="45720" marB="45720" anchor="ctr">
+                    <a:lnL w="9525" cap="flat" cmpd="sng" algn="ctr">
+                      <a:solidFill>
+                        <a:srgbClr val="E2E8F0"/>
+                      </a:solidFill>
+                      <a:prstDash val="solid"/>
+                      <a:round/>
+                      <a:headEnd type="none" w="med" len="med"/>
+                      <a:tailEnd type="none" w="med" len="med"/>
+                    </a:lnL>
+                    <a:lnR w="9525" cap="flat" cmpd="sng" algn="ctr">
+                      <a:solidFill>
+                        <a:srgbClr val="E2E8F0"/>
+                      </a:solidFill>
+                      <a:prstDash val="solid"/>
+                      <a:round/>
+                      <a:headEnd type="none" w="med" len="med"/>
+                      <a:tailEnd type="none" w="med" len="med"/>
+                    </a:lnR>
+                    <a:lnT w="9525" cap="flat" cmpd="sng" algn="ctr">
+                      <a:solidFill>
+                        <a:srgbClr val="E2E8F0"/>
+                      </a:solidFill>
+                      <a:prstDash val="solid"/>
+                      <a:round/>
+                      <a:headEnd type="none" w="med" len="med"/>
+                      <a:tailEnd type="none" w="med" len="med"/>
+                    </a:lnT>
+                    <a:lnB w="9525" cap="flat" cmpd="sng" algn="ctr">
+                      <a:solidFill>
+                        <a:srgbClr val="E2E8F0"/>
+                      </a:solidFill>
+                      <a:prstDash val="solid"/>
+                      <a:round/>
+                      <a:headEnd type="none" w="med" len="med"/>
+                      <a:tailEnd type="none" w="med" len="med"/>
+                    </a:lnB>
+                    <a:solidFill>
+                      <a:srgbClr val="FFFFFF"/>
+                    </a:solidFill>
+                  </a:tcPr>
+                </a:tc>
+                <a:tc>
+                  <a:txBody>
+                    <a:bodyPr/>
+                    <a:lstStyle/>
+                    <a:p>
+                      <a:pPr algn="ctr" indent="0" marL="0">
+                        <a:buNone/>
+                      </a:pPr>
+                      <a:r>
+                        <a:rPr lang="en-US" sz="1100" dirty="0">
+                          <a:solidFill>
+                            <a:srgbClr val="1F3B57"/>
+                          </a:solidFill>
+                          <a:latin typeface="Arial" pitchFamily="34" charset="0"/>
+                          <a:ea typeface="Arial" pitchFamily="34" charset="-122"/>
+                          <a:cs typeface="Arial" pitchFamily="34" charset="-120"/>
+                        </a:rPr>
+                        <a:t>0.947</a:t>
+                      </a:r>
+                      <a:endParaRPr lang="en-US" sz="1100" dirty="0">
+                        <a:latin typeface="Arial" charset="0"/>
+                        <a:ea typeface="Arial" charset="0"/>
+                        <a:cs typeface="Arial" charset="0"/>
+                      </a:endParaRPr>
+                    </a:p>
+                  </a:txBody>
+                  <a:tcPr marL="91440" marR="91440" marT="45720" marB="45720" anchor="ctr">
+                    <a:lnL w="9525" cap="flat" cmpd="sng" algn="ctr">
+                      <a:solidFill>
+                        <a:srgbClr val="E2E8F0"/>
+                      </a:solidFill>
+                      <a:prstDash val="solid"/>
+                      <a:round/>
+                      <a:headEnd type="none" w="med" len="med"/>
+                      <a:tailEnd type="none" w="med" len="med"/>
+                    </a:lnL>
+                    <a:lnR w="9525" cap="flat" cmpd="sng" algn="ctr">
+                      <a:solidFill>
+                        <a:srgbClr val="E2E8F0"/>
+                      </a:solidFill>
+                      <a:prstDash val="solid"/>
+                      <a:round/>
+                      <a:headEnd type="none" w="med" len="med"/>
+                      <a:tailEnd type="none" w="med" len="med"/>
+                    </a:lnR>
+                    <a:lnT w="9525" cap="flat" cmpd="sng" algn="ctr">
+                      <a:solidFill>
+                        <a:srgbClr val="E2E8F0"/>
+                      </a:solidFill>
+                      <a:prstDash val="solid"/>
+                      <a:round/>
+                      <a:headEnd type="none" w="med" len="med"/>
+                      <a:tailEnd type="none" w="med" len="med"/>
+                    </a:lnT>
+                    <a:lnB w="9525" cap="flat" cmpd="sng" algn="ctr">
+                      <a:solidFill>
+                        <a:srgbClr val="E2E8F0"/>
+                      </a:solidFill>
+                      <a:prstDash val="solid"/>
+                      <a:round/>
+                      <a:headEnd type="none" w="med" len="med"/>
+                      <a:tailEnd type="none" w="med" len="med"/>
+                    </a:lnB>
+                    <a:solidFill>
+                      <a:srgbClr val="FFFFFF"/>
+                    </a:solidFill>
+                  </a:tcPr>
+                </a:tc>
+                <a:tc>
+                  <a:txBody>
+                    <a:bodyPr/>
+                    <a:lstStyle/>
+                    <a:p>
+                      <a:pPr algn="ctr" indent="0" marL="0">
+                        <a:buNone/>
+                      </a:pPr>
+                      <a:r>
+                        <a:rPr lang="en-US" sz="1100" dirty="0">
+                          <a:solidFill>
+                            <a:srgbClr val="1F3B57"/>
+                          </a:solidFill>
+                          <a:latin typeface="Arial" pitchFamily="34" charset="0"/>
+                          <a:ea typeface="Arial" pitchFamily="34" charset="-122"/>
+                          <a:cs typeface="Arial" pitchFamily="34" charset="-120"/>
+                        </a:rPr>
+                        <a:t>0.740</a:t>
+                      </a:r>
+                      <a:endParaRPr lang="en-US" sz="1100" dirty="0">
+                        <a:latin typeface="Arial" charset="0"/>
+                        <a:ea typeface="Arial" charset="0"/>
+                        <a:cs typeface="Arial" charset="0"/>
+                      </a:endParaRPr>
+                    </a:p>
+                  </a:txBody>
+                  <a:tcPr marL="91440" marR="91440" marT="45720" marB="45720" anchor="ctr">
+                    <a:lnL w="9525" cap="flat" cmpd="sng" algn="ctr">
+                      <a:solidFill>
+                        <a:srgbClr val="E2E8F0"/>
+                      </a:solidFill>
+                      <a:prstDash val="solid"/>
+                      <a:round/>
+                      <a:headEnd type="none" w="med" len="med"/>
+                      <a:tailEnd type="none" w="med" len="med"/>
+                    </a:lnL>
+                    <a:lnR w="9525" cap="flat" cmpd="sng" algn="ctr">
+                      <a:solidFill>
+                        <a:srgbClr val="E2E8F0"/>
+                      </a:solidFill>
+                      <a:prstDash val="solid"/>
+                      <a:round/>
+                      <a:headEnd type="none" w="med" len="med"/>
+                      <a:tailEnd type="none" w="med" len="med"/>
+                    </a:lnR>
+                    <a:lnT w="9525" cap="flat" cmpd="sng" algn="ctr">
+                      <a:solidFill>
+                        <a:srgbClr val="E2E8F0"/>
+                      </a:solidFill>
+                      <a:prstDash val="solid"/>
+                      <a:round/>
+                      <a:headEnd type="none" w="med" len="med"/>
+                      <a:tailEnd type="none" w="med" len="med"/>
+                    </a:lnT>
+                    <a:lnB w="9525" cap="flat" cmpd="sng" algn="ctr">
+                      <a:solidFill>
+                        <a:srgbClr val="E2E8F0"/>
+                      </a:solidFill>
+                      <a:prstDash val="solid"/>
+                      <a:round/>
+                      <a:headEnd type="none" w="med" len="med"/>
+                      <a:tailEnd type="none" w="med" len="med"/>
+                    </a:lnB>
+                    <a:solidFill>
+                      <a:srgbClr val="FFFFFF"/>
+                    </a:solidFill>
+                  </a:tcPr>
+                </a:tc>
+                <a:tc>
+                  <a:txBody>
+                    <a:bodyPr/>
+                    <a:lstStyle/>
+                    <a:p>
+                      <a:pPr algn="ctr" indent="0" marL="0">
+                        <a:buNone/>
+                      </a:pPr>
+                      <a:r>
+                        <a:rPr lang="en-US" sz="1100" dirty="0">
+                          <a:solidFill>
+                            <a:srgbClr val="1F3B57"/>
+                          </a:solidFill>
+                          <a:latin typeface="Arial" pitchFamily="34" charset="0"/>
+                          <a:ea typeface="Arial" pitchFamily="34" charset="-122"/>
+                          <a:cs typeface="Arial" pitchFamily="34" charset="-120"/>
+                        </a:rPr>
+                        <a:t>0.780</a:t>
+                      </a:r>
+                      <a:endParaRPr lang="en-US" sz="1100" dirty="0">
+                        <a:latin typeface="Arial" charset="0"/>
+                        <a:ea typeface="Arial" charset="0"/>
+                        <a:cs typeface="Arial" charset="0"/>
+                      </a:endParaRPr>
+                    </a:p>
+                  </a:txBody>
+                  <a:tcPr marL="91440" marR="91440" marT="45720" marB="45720" anchor="ctr">
+                    <a:lnL w="9525" cap="flat" cmpd="sng" algn="ctr">
+                      <a:solidFill>
+                        <a:srgbClr val="E2E8F0"/>
+                      </a:solidFill>
+                      <a:prstDash val="solid"/>
+                      <a:round/>
+                      <a:headEnd type="none" w="med" len="med"/>
+                      <a:tailEnd type="none" w="med" len="med"/>
+                    </a:lnL>
+                    <a:lnR w="9525" cap="flat" cmpd="sng" algn="ctr">
+                      <a:solidFill>
+                        <a:srgbClr val="E2E8F0"/>
+                      </a:solidFill>
+                      <a:prstDash val="solid"/>
+                      <a:round/>
+                      <a:headEnd type="none" w="med" len="med"/>
+                      <a:tailEnd type="none" w="med" len="med"/>
+                    </a:lnR>
+                    <a:lnT w="9525" cap="flat" cmpd="sng" algn="ctr">
+                      <a:solidFill>
+                        <a:srgbClr val="E2E8F0"/>
+                      </a:solidFill>
+                      <a:prstDash val="solid"/>
+                      <a:round/>
+                      <a:headEnd type="none" w="med" len="med"/>
+                      <a:tailEnd type="none" w="med" len="med"/>
+                    </a:lnT>
+                    <a:lnB w="9525" cap="flat" cmpd="sng" algn="ctr">
+                      <a:solidFill>
+                        <a:srgbClr val="E2E8F0"/>
+                      </a:solidFill>
+                      <a:prstDash val="solid"/>
+                      <a:round/>
+                      <a:headEnd type="none" w="med" len="med"/>
+                      <a:tailEnd type="none" w="med" len="med"/>
+                    </a:lnB>
+                    <a:solidFill>
+                      <a:srgbClr val="FFFFFF"/>
+                    </a:solidFill>
+                  </a:tcPr>
+                </a:tc>
+                <a:tc>
+                  <a:txBody>
+                    <a:bodyPr/>
+                    <a:lstStyle/>
+                    <a:p>
+                      <a:pPr algn="ctr" indent="0" marL="0">
+                        <a:buNone/>
+                      </a:pPr>
+                      <a:r>
+                        <a:rPr lang="en-US" sz="1100" b="1" dirty="0">
+                          <a:solidFill>
+                            <a:srgbClr val="1F3B57"/>
+                          </a:solidFill>
+                          <a:latin typeface="Arial" pitchFamily="34" charset="0"/>
+                          <a:ea typeface="Arial" pitchFamily="34" charset="-122"/>
+                          <a:cs typeface="Arial" pitchFamily="34" charset="-120"/>
+                        </a:rPr>
+                        <a:t>0.840</a:t>
+                      </a:r>
+                      <a:endParaRPr lang="en-US" sz="1100" dirty="0">
+                        <a:latin typeface="Arial" charset="0"/>
+                        <a:ea typeface="Arial" charset="0"/>
+                        <a:cs typeface="Arial" charset="0"/>
+                      </a:endParaRPr>
+                    </a:p>
+                  </a:txBody>
+                  <a:tcPr marL="91440" marR="91440" marT="45720" marB="45720" anchor="ctr">
+                    <a:lnL w="9525" cap="flat" cmpd="sng" algn="ctr">
+                      <a:solidFill>
+                        <a:srgbClr val="E2E8F0"/>
+                      </a:solidFill>
+                      <a:prstDash val="solid"/>
+                      <a:round/>
+                      <a:headEnd type="none" w="med" len="med"/>
+                      <a:tailEnd type="none" w="med" len="med"/>
+                    </a:lnL>
+                    <a:lnR w="9525" cap="flat" cmpd="sng" algn="ctr">
+                      <a:solidFill>
+                        <a:srgbClr val="E2E8F0"/>
+                      </a:solidFill>
+                      <a:prstDash val="solid"/>
+                      <a:round/>
+                      <a:headEnd type="none" w="med" len="med"/>
+                      <a:tailEnd type="none" w="med" len="med"/>
+                    </a:lnR>
+                    <a:lnT w="9525" cap="flat" cmpd="sng" algn="ctr">
+                      <a:solidFill>
+                        <a:srgbClr val="E2E8F0"/>
+                      </a:solidFill>
+                      <a:prstDash val="solid"/>
+                      <a:round/>
+                      <a:headEnd type="none" w="med" len="med"/>
+                      <a:tailEnd type="none" w="med" len="med"/>
+                    </a:lnT>
+                    <a:lnB w="9525" cap="flat" cmpd="sng" algn="ctr">
+                      <a:solidFill>
+                        <a:srgbClr val="E2E8F0"/>
+                      </a:solidFill>
+                      <a:prstDash val="solid"/>
+                      <a:round/>
+                      <a:headEnd type="none" w="med" len="med"/>
+                      <a:tailEnd type="none" w="med" len="med"/>
+                    </a:lnB>
+                    <a:solidFill>
+                      <a:srgbClr val="FFFFFF"/>
+                    </a:solidFill>
+                  </a:tcPr>
+                </a:tc>
+                <a:tc>
+                  <a:txBody>
+                    <a:bodyPr/>
+                    <a:lstStyle/>
+                    <a:p>
+                      <a:pPr algn="ctr" indent="0" marL="0">
+                        <a:buNone/>
+                      </a:pPr>
+                      <a:r>
+                        <a:rPr lang="en-US" sz="1100" dirty="0">
+                          <a:solidFill>
+                            <a:srgbClr val="1F3B57"/>
+                          </a:solidFill>
+                          <a:latin typeface="Arial" pitchFamily="34" charset="0"/>
+                          <a:ea typeface="Arial" pitchFamily="34" charset="-122"/>
+                          <a:cs typeface="Arial" pitchFamily="34" charset="-120"/>
+                        </a:rPr>
+                        <a:t>0.420</a:t>
+                      </a:r>
+                      <a:endParaRPr lang="en-US" sz="1100" dirty="0">
+                        <a:latin typeface="Arial" charset="0"/>
+                        <a:ea typeface="Arial" charset="0"/>
+                        <a:cs typeface="Arial" charset="0"/>
+                      </a:endParaRPr>
+                    </a:p>
+                  </a:txBody>
+                  <a:tcPr marL="91440" marR="91440" marT="45720" marB="45720" anchor="ctr">
+                    <a:lnL w="9525" cap="flat" cmpd="sng" algn="ctr">
+                      <a:solidFill>
+                        <a:srgbClr val="E2E8F0"/>
+                      </a:solidFill>
+                      <a:prstDash val="solid"/>
+                      <a:round/>
+                      <a:headEnd type="none" w="med" len="med"/>
+                      <a:tailEnd type="none" w="med" len="med"/>
+                    </a:lnL>
+                    <a:lnR w="9525" cap="flat" cmpd="sng" algn="ctr">
+                      <a:solidFill>
+                        <a:srgbClr val="E2E8F0"/>
+                      </a:solidFill>
+                      <a:prstDash val="solid"/>
+                      <a:round/>
+                      <a:headEnd type="none" w="med" len="med"/>
+                      <a:tailEnd type="none" w="med" len="med"/>
+                    </a:lnR>
+                    <a:lnT w="9525" cap="flat" cmpd="sng" algn="ctr">
+                      <a:solidFill>
+                        <a:srgbClr val="E2E8F0"/>
+                      </a:solidFill>
+                      <a:prstDash val="solid"/>
+                      <a:round/>
+                      <a:headEnd type="none" w="med" len="med"/>
+                      <a:tailEnd type="none" w="med" len="med"/>
+                    </a:lnT>
+                    <a:lnB w="9525" cap="flat" cmpd="sng" algn="ctr">
+                      <a:solidFill>
+                        <a:srgbClr val="E2E8F0"/>
+                      </a:solidFill>
+                      <a:prstDash val="solid"/>
+                      <a:round/>
+                      <a:headEnd type="none" w="med" len="med"/>
+                      <a:tailEnd type="none" w="med" len="med"/>
+                    </a:lnB>
+                    <a:solidFill>
+                      <a:srgbClr val="FFFFFF"/>
+                    </a:solidFill>
+                  </a:tcPr>
+                </a:tc>
+              </a:tr>
+              <a:tr h="402336">
+                <a:tc>
+                  <a:txBody>
+                    <a:bodyPr/>
+                    <a:lstStyle/>
+                    <a:p>
+                      <a:pPr algn="ctr" indent="0" marL="0">
+                        <a:buNone/>
+                      </a:pPr>
+                      <a:r>
+                        <a:rPr lang="en-US" sz="1100" b="1" dirty="0">
+                          <a:solidFill>
+                            <a:srgbClr val="1F3B57"/>
+                          </a:solidFill>
+                          <a:latin typeface="Arial" pitchFamily="34" charset="0"/>
+                          <a:ea typeface="Arial" pitchFamily="34" charset="-122"/>
+                          <a:cs typeface="Arial" pitchFamily="34" charset="-120"/>
+                        </a:rPr>
+                        <a:t>4층부터 차단 (T4)</a:t>
+                      </a:r>
+                      <a:endParaRPr lang="en-US" sz="1100" dirty="0">
+                        <a:latin typeface="Arial" charset="0"/>
+                        <a:ea typeface="Arial" charset="0"/>
+                        <a:cs typeface="Arial" charset="0"/>
+                      </a:endParaRPr>
+                    </a:p>
+                  </a:txBody>
+                  <a:tcPr marL="91440" marR="91440" marT="45720" marB="45720" anchor="ctr">
+                    <a:lnL w="9525" cap="flat" cmpd="sng" algn="ctr">
+                      <a:solidFill>
+                        <a:srgbClr val="E2E8F0"/>
+                      </a:solidFill>
+                      <a:prstDash val="solid"/>
+                      <a:round/>
+                      <a:headEnd type="none" w="med" len="med"/>
+                      <a:tailEnd type="none" w="med" len="med"/>
+                    </a:lnL>
+                    <a:lnR w="9525" cap="flat" cmpd="sng" algn="ctr">
+                      <a:solidFill>
+                        <a:srgbClr val="E2E8F0"/>
+                      </a:solidFill>
+                      <a:prstDash val="solid"/>
+                      <a:round/>
+                      <a:headEnd type="none" w="med" len="med"/>
+                      <a:tailEnd type="none" w="med" len="med"/>
+                    </a:lnR>
+                    <a:lnT w="9525" cap="flat" cmpd="sng" algn="ctr">
+                      <a:solidFill>
+                        <a:srgbClr val="E2E8F0"/>
+                      </a:solidFill>
+                      <a:prstDash val="solid"/>
+                      <a:round/>
+                      <a:headEnd type="none" w="med" len="med"/>
+                      <a:tailEnd type="none" w="med" len="med"/>
+                    </a:lnT>
+                    <a:lnB w="9525" cap="flat" cmpd="sng" algn="ctr">
+                      <a:solidFill>
+                        <a:srgbClr val="E2E8F0"/>
+                      </a:solidFill>
+                      <a:prstDash val="solid"/>
+                      <a:round/>
+                      <a:headEnd type="none" w="med" len="med"/>
+                      <a:tailEnd type="none" w="med" len="med"/>
+                    </a:lnB>
+                    <a:solidFill>
+                      <a:srgbClr val="FFFFFF"/>
+                    </a:solidFill>
+                  </a:tcPr>
+                </a:tc>
+                <a:tc>
+                  <a:txBody>
+                    <a:bodyPr/>
+                    <a:lstStyle/>
+                    <a:p>
+                      <a:pPr algn="ctr" indent="0" marL="0">
+                        <a:buNone/>
+                      </a:pPr>
+                      <a:r>
+                        <a:rPr lang="en-US" sz="1100" dirty="0">
+                          <a:solidFill>
+                            <a:srgbClr val="2E8B57"/>
+                          </a:solidFill>
+                          <a:latin typeface="Arial" pitchFamily="34" charset="0"/>
+                          <a:ea typeface="Arial" pitchFamily="34" charset="-122"/>
+                          <a:cs typeface="Arial" pitchFamily="34" charset="-120"/>
+                        </a:rPr>
+                        <a:t>0.920</a:t>
+                      </a:r>
+                      <a:endParaRPr lang="en-US" sz="1100" dirty="0">
+                        <a:latin typeface="Arial" charset="0"/>
+                        <a:ea typeface="Arial" charset="0"/>
+                        <a:cs typeface="Arial" charset="0"/>
+                      </a:endParaRPr>
+                    </a:p>
+                  </a:txBody>
+                  <a:tcPr marL="91440" marR="91440" marT="45720" marB="45720" anchor="ctr">
+                    <a:lnL w="9525" cap="flat" cmpd="sng" algn="ctr">
+                      <a:solidFill>
+                        <a:srgbClr val="E2E8F0"/>
+                      </a:solidFill>
+                      <a:prstDash val="solid"/>
+                      <a:round/>
+                      <a:headEnd type="none" w="med" len="med"/>
+                      <a:tailEnd type="none" w="med" len="med"/>
+                    </a:lnL>
+                    <a:lnR w="9525" cap="flat" cmpd="sng" algn="ctr">
+                      <a:solidFill>
+                        <a:srgbClr val="E2E8F0"/>
+                      </a:solidFill>
+                      <a:prstDash val="solid"/>
+                      <a:round/>
+                      <a:headEnd type="none" w="med" len="med"/>
+                      <a:tailEnd type="none" w="med" len="med"/>
+                    </a:lnR>
+                    <a:lnT w="9525" cap="flat" cmpd="sng" algn="ctr">
+                      <a:solidFill>
+                        <a:srgbClr val="E2E8F0"/>
+                      </a:solidFill>
+                      <a:prstDash val="solid"/>
+                      <a:round/>
+                      <a:headEnd type="none" w="med" len="med"/>
+                      <a:tailEnd type="none" w="med" len="med"/>
+                    </a:lnT>
+                    <a:lnB w="9525" cap="flat" cmpd="sng" algn="ctr">
+                      <a:solidFill>
+                        <a:srgbClr val="E2E8F0"/>
+                      </a:solidFill>
+                      <a:prstDash val="solid"/>
+                      <a:round/>
+                      <a:headEnd type="none" w="med" len="med"/>
+                      <a:tailEnd type="none" w="med" len="med"/>
+                    </a:lnB>
+                    <a:solidFill>
+                      <a:srgbClr val="FFFFFF"/>
+                    </a:solidFill>
+                  </a:tcPr>
+                </a:tc>
+                <a:tc>
+                  <a:txBody>
+                    <a:bodyPr/>
+                    <a:lstStyle/>
+                    <a:p>
+                      <a:pPr algn="ctr" indent="0" marL="0">
+                        <a:buNone/>
+                      </a:pPr>
+                      <a:r>
+                        <a:rPr lang="en-US" sz="1100" dirty="0">
+                          <a:solidFill>
+                            <a:srgbClr val="2E8B57"/>
+                          </a:solidFill>
+                          <a:latin typeface="Arial" pitchFamily="34" charset="0"/>
+                          <a:ea typeface="Arial" pitchFamily="34" charset="-122"/>
+                          <a:cs typeface="Arial" pitchFamily="34" charset="-120"/>
+                        </a:rPr>
+                        <a:t>0.960</a:t>
+                      </a:r>
+                      <a:endParaRPr lang="en-US" sz="1100" dirty="0">
+                        <a:latin typeface="Arial" charset="0"/>
+                        <a:ea typeface="Arial" charset="0"/>
+                        <a:cs typeface="Arial" charset="0"/>
+                      </a:endParaRPr>
+                    </a:p>
+                  </a:txBody>
+                  <a:tcPr marL="91440" marR="91440" marT="45720" marB="45720" anchor="ctr">
+                    <a:lnL w="9525" cap="flat" cmpd="sng" algn="ctr">
+                      <a:solidFill>
+                        <a:srgbClr val="E2E8F0"/>
+                      </a:solidFill>
+                      <a:prstDash val="solid"/>
+                      <a:round/>
+                      <a:headEnd type="none" w="med" len="med"/>
+                      <a:tailEnd type="none" w="med" len="med"/>
+                    </a:lnL>
+                    <a:lnR w="9525" cap="flat" cmpd="sng" algn="ctr">
+                      <a:solidFill>
+                        <a:srgbClr val="E2E8F0"/>
+                      </a:solidFill>
+                      <a:prstDash val="solid"/>
+                      <a:round/>
+                      <a:headEnd type="none" w="med" len="med"/>
+                      <a:tailEnd type="none" w="med" len="med"/>
+                    </a:lnR>
+                    <a:lnT w="9525" cap="flat" cmpd="sng" algn="ctr">
+                      <a:solidFill>
+                        <a:srgbClr val="E2E8F0"/>
+                      </a:solidFill>
+                      <a:prstDash val="solid"/>
+                      <a:round/>
+                      <a:headEnd type="none" w="med" len="med"/>
+                      <a:tailEnd type="none" w="med" len="med"/>
+                    </a:lnT>
+                    <a:lnB w="9525" cap="flat" cmpd="sng" algn="ctr">
+                      <a:solidFill>
+                        <a:srgbClr val="E2E8F0"/>
+                      </a:solidFill>
+                      <a:prstDash val="solid"/>
+                      <a:round/>
+                      <a:headEnd type="none" w="med" len="med"/>
+                      <a:tailEnd type="none" w="med" len="med"/>
+                    </a:lnB>
+                    <a:solidFill>
+                      <a:srgbClr val="FFFFFF"/>
+                    </a:solidFill>
+                  </a:tcPr>
+                </a:tc>
+                <a:tc>
+                  <a:txBody>
+                    <a:bodyPr/>
+                    <a:lstStyle/>
+                    <a:p>
+                      <a:pPr algn="ctr" indent="0" marL="0">
+                        <a:buNone/>
+                      </a:pPr>
+                      <a:r>
+                        <a:rPr lang="en-US" sz="1100" dirty="0">
+                          <a:solidFill>
+                            <a:srgbClr val="D62728"/>
+                          </a:solidFill>
+                          <a:latin typeface="Arial" pitchFamily="34" charset="0"/>
+                          <a:ea typeface="Arial" pitchFamily="34" charset="-122"/>
+                          <a:cs typeface="Arial" pitchFamily="34" charset="-120"/>
+                        </a:rPr>
+                        <a:t>0.720</a:t>
+                      </a:r>
+                      <a:endParaRPr lang="en-US" sz="1100" dirty="0">
+                        <a:latin typeface="Arial" charset="0"/>
+                        <a:ea typeface="Arial" charset="0"/>
+                        <a:cs typeface="Arial" charset="0"/>
+                      </a:endParaRPr>
+                    </a:p>
+                  </a:txBody>
+                  <a:tcPr marL="91440" marR="91440" marT="45720" marB="45720" anchor="ctr">
+                    <a:lnL w="9525" cap="flat" cmpd="sng" algn="ctr">
+                      <a:solidFill>
+                        <a:srgbClr val="E2E8F0"/>
+                      </a:solidFill>
+                      <a:prstDash val="solid"/>
+                      <a:round/>
+                      <a:headEnd type="none" w="med" len="med"/>
+                      <a:tailEnd type="none" w="med" len="med"/>
+                    </a:lnL>
+                    <a:lnR w="9525" cap="flat" cmpd="sng" algn="ctr">
+                      <a:solidFill>
+                        <a:srgbClr val="E2E8F0"/>
+                      </a:solidFill>
+                      <a:prstDash val="solid"/>
+                      <a:round/>
+                      <a:headEnd type="none" w="med" len="med"/>
+                      <a:tailEnd type="none" w="med" len="med"/>
+                    </a:lnR>
+                    <a:lnT w="9525" cap="flat" cmpd="sng" algn="ctr">
+                      <a:solidFill>
+                        <a:srgbClr val="E2E8F0"/>
+                      </a:solidFill>
+                      <a:prstDash val="solid"/>
+                      <a:round/>
+                      <a:headEnd type="none" w="med" len="med"/>
+                      <a:tailEnd type="none" w="med" len="med"/>
+                    </a:lnT>
+                    <a:lnB w="9525" cap="flat" cmpd="sng" algn="ctr">
+                      <a:solidFill>
+                        <a:srgbClr val="E2E8F0"/>
+                      </a:solidFill>
+                      <a:prstDash val="solid"/>
+                      <a:round/>
+                      <a:headEnd type="none" w="med" len="med"/>
+                      <a:tailEnd type="none" w="med" len="med"/>
+                    </a:lnB>
+                    <a:solidFill>
+                      <a:srgbClr val="FFFFFF"/>
+                    </a:solidFill>
+                  </a:tcPr>
+                </a:tc>
+                <a:tc>
+                  <a:txBody>
+                    <a:bodyPr/>
+                    <a:lstStyle/>
+                    <a:p>
+                      <a:pPr algn="ctr" indent="0" marL="0">
+                        <a:buNone/>
+                      </a:pPr>
+                      <a:r>
+                        <a:rPr lang="en-US" sz="1100" dirty="0">
+                          <a:solidFill>
+                            <a:srgbClr val="D62728"/>
+                          </a:solidFill>
+                          <a:latin typeface="Arial" pitchFamily="34" charset="0"/>
+                          <a:ea typeface="Arial" pitchFamily="34" charset="-122"/>
+                          <a:cs typeface="Arial" pitchFamily="34" charset="-120"/>
+                        </a:rPr>
+                        <a:t>0.767</a:t>
+                      </a:r>
+                      <a:endParaRPr lang="en-US" sz="1100" dirty="0">
+                        <a:latin typeface="Arial" charset="0"/>
+                        <a:ea typeface="Arial" charset="0"/>
+                        <a:cs typeface="Arial" charset="0"/>
+                      </a:endParaRPr>
+                    </a:p>
+                  </a:txBody>
+                  <a:tcPr marL="91440" marR="91440" marT="45720" marB="45720" anchor="ctr">
+                    <a:lnL w="9525" cap="flat" cmpd="sng" algn="ctr">
+                      <a:solidFill>
+                        <a:srgbClr val="E2E8F0"/>
+                      </a:solidFill>
+                      <a:prstDash val="solid"/>
+                      <a:round/>
+                      <a:headEnd type="none" w="med" len="med"/>
+                      <a:tailEnd type="none" w="med" len="med"/>
+                    </a:lnL>
+                    <a:lnR w="9525" cap="flat" cmpd="sng" algn="ctr">
+                      <a:solidFill>
+                        <a:srgbClr val="E2E8F0"/>
+                      </a:solidFill>
+                      <a:prstDash val="solid"/>
+                      <a:round/>
+                      <a:headEnd type="none" w="med" len="med"/>
+                      <a:tailEnd type="none" w="med" len="med"/>
+                    </a:lnR>
+                    <a:lnT w="9525" cap="flat" cmpd="sng" algn="ctr">
+                      <a:solidFill>
+                        <a:srgbClr val="E2E8F0"/>
+                      </a:solidFill>
+                      <a:prstDash val="solid"/>
+                      <a:round/>
+                      <a:headEnd type="none" w="med" len="med"/>
+                      <a:tailEnd type="none" w="med" len="med"/>
+                    </a:lnT>
+                    <a:lnB w="9525" cap="flat" cmpd="sng" algn="ctr">
+                      <a:solidFill>
+                        <a:srgbClr val="E2E8F0"/>
+                      </a:solidFill>
+                      <a:prstDash val="solid"/>
+                      <a:round/>
+                      <a:headEnd type="none" w="med" len="med"/>
+                      <a:tailEnd type="none" w="med" len="med"/>
+                    </a:lnB>
+                    <a:solidFill>
+                      <a:srgbClr val="FFFFFF"/>
+                    </a:solidFill>
+                  </a:tcPr>
+                </a:tc>
+                <a:tc>
+                  <a:txBody>
+                    <a:bodyPr/>
+                    <a:lstStyle/>
+                    <a:p>
+                      <a:pPr algn="ctr" indent="0" marL="0">
+                        <a:buNone/>
+                      </a:pPr>
+                      <a:r>
+                        <a:rPr lang="en-US" sz="1100" b="1" dirty="0">
+                          <a:solidFill>
+                            <a:srgbClr val="1F3B57"/>
+                          </a:solidFill>
+                          <a:latin typeface="Arial" pitchFamily="34" charset="0"/>
+                          <a:ea typeface="Arial" pitchFamily="34" charset="-122"/>
+                          <a:cs typeface="Arial" pitchFamily="34" charset="-120"/>
+                        </a:rPr>
+                        <a:t>0.842</a:t>
+                      </a:r>
+                      <a:endParaRPr lang="en-US" sz="1100" dirty="0">
+                        <a:latin typeface="Arial" charset="0"/>
+                        <a:ea typeface="Arial" charset="0"/>
+                        <a:cs typeface="Arial" charset="0"/>
+                      </a:endParaRPr>
+                    </a:p>
+                  </a:txBody>
+                  <a:tcPr marL="91440" marR="91440" marT="45720" marB="45720" anchor="ctr">
+                    <a:lnL w="9525" cap="flat" cmpd="sng" algn="ctr">
+                      <a:solidFill>
+                        <a:srgbClr val="E2E8F0"/>
+                      </a:solidFill>
+                      <a:prstDash val="solid"/>
+                      <a:round/>
+                      <a:headEnd type="none" w="med" len="med"/>
+                      <a:tailEnd type="none" w="med" len="med"/>
+                    </a:lnL>
+                    <a:lnR w="9525" cap="flat" cmpd="sng" algn="ctr">
+                      <a:solidFill>
+                        <a:srgbClr val="E2E8F0"/>
+                      </a:solidFill>
+                      <a:prstDash val="solid"/>
+                      <a:round/>
+                      <a:headEnd type="none" w="med" len="med"/>
+                      <a:tailEnd type="none" w="med" len="med"/>
+                    </a:lnR>
+                    <a:lnT w="9525" cap="flat" cmpd="sng" algn="ctr">
+                      <a:solidFill>
+                        <a:srgbClr val="E2E8F0"/>
+                      </a:solidFill>
+                      <a:prstDash val="solid"/>
+                      <a:round/>
+                      <a:headEnd type="none" w="med" len="med"/>
+                      <a:tailEnd type="none" w="med" len="med"/>
+                    </a:lnT>
+                    <a:lnB w="9525" cap="flat" cmpd="sng" algn="ctr">
+                      <a:solidFill>
+                        <a:srgbClr val="E2E8F0"/>
+                      </a:solidFill>
+                      <a:prstDash val="solid"/>
+                      <a:round/>
+                      <a:headEnd type="none" w="med" len="med"/>
+                      <a:tailEnd type="none" w="med" len="med"/>
+                    </a:lnB>
+                    <a:solidFill>
+                      <a:srgbClr val="FFFFFF"/>
+                    </a:solidFill>
+                  </a:tcPr>
+                </a:tc>
+                <a:tc>
+                  <a:txBody>
+                    <a:bodyPr/>
+                    <a:lstStyle/>
+                    <a:p>
+                      <a:pPr algn="ctr" indent="0" marL="0">
+                        <a:buNone/>
+                      </a:pPr>
+                      <a:r>
+                        <a:rPr lang="en-US" sz="1100" dirty="0">
+                          <a:solidFill>
+                            <a:srgbClr val="1F3B57"/>
+                          </a:solidFill>
+                          <a:latin typeface="Arial" pitchFamily="34" charset="0"/>
+                          <a:ea typeface="Arial" pitchFamily="34" charset="-122"/>
+                          <a:cs typeface="Arial" pitchFamily="34" charset="-120"/>
+                        </a:rPr>
+                        <a:t>0.402</a:t>
+                      </a:r>
+                      <a:endParaRPr lang="en-US" sz="1100" dirty="0">
+                        <a:latin typeface="Arial" charset="0"/>
+                        <a:ea typeface="Arial" charset="0"/>
+                        <a:cs typeface="Arial" charset="0"/>
+                      </a:endParaRPr>
+                    </a:p>
+                  </a:txBody>
+                  <a:tcPr marL="91440" marR="91440" marT="45720" marB="45720" anchor="ctr">
+                    <a:lnL w="9525" cap="flat" cmpd="sng" algn="ctr">
+                      <a:solidFill>
+                        <a:srgbClr val="E2E8F0"/>
+                      </a:solidFill>
+                      <a:prstDash val="solid"/>
+                      <a:round/>
+                      <a:headEnd type="none" w="med" len="med"/>
+                      <a:tailEnd type="none" w="med" len="med"/>
+                    </a:lnL>
+                    <a:lnR w="9525" cap="flat" cmpd="sng" algn="ctr">
+                      <a:solidFill>
+                        <a:srgbClr val="E2E8F0"/>
+                      </a:solidFill>
+                      <a:prstDash val="solid"/>
+                      <a:round/>
+                      <a:headEnd type="none" w="med" len="med"/>
+                      <a:tailEnd type="none" w="med" len="med"/>
+                    </a:lnR>
+                    <a:lnT w="9525" cap="flat" cmpd="sng" algn="ctr">
+                      <a:solidFill>
+                        <a:srgbClr val="E2E8F0"/>
+                      </a:solidFill>
+                      <a:prstDash val="solid"/>
+                      <a:round/>
+                      <a:headEnd type="none" w="med" len="med"/>
+                      <a:tailEnd type="none" w="med" len="med"/>
+                    </a:lnT>
+                    <a:lnB w="9525" cap="flat" cmpd="sng" algn="ctr">
+                      <a:solidFill>
+                        <a:srgbClr val="E2E8F0"/>
+                      </a:solidFill>
+                      <a:prstDash val="solid"/>
+                      <a:round/>
+                      <a:headEnd type="none" w="med" len="med"/>
+                      <a:tailEnd type="none" w="med" len="med"/>
+                    </a:lnB>
+                    <a:solidFill>
+                      <a:srgbClr val="FFFFFF"/>
+                    </a:solidFill>
+                  </a:tcPr>
+                </a:tc>
+              </a:tr>
+              <a:tr h="402336">
+                <a:tc>
+                  <a:txBody>
+                    <a:bodyPr/>
+                    <a:lstStyle/>
+                    <a:p>
+                      <a:pPr algn="ctr" indent="0" marL="0">
+                        <a:buNone/>
+                      </a:pPr>
+                      <a:r>
+                        <a:rPr lang="en-US" sz="1100" b="1" dirty="0">
+                          <a:solidFill>
+                            <a:srgbClr val="1F3B57"/>
+                          </a:solidFill>
+                          <a:latin typeface="Arial" pitchFamily="34" charset="0"/>
+                          <a:ea typeface="Arial" pitchFamily="34" charset="-122"/>
+                          <a:cs typeface="Arial" pitchFamily="34" charset="-120"/>
+                        </a:rPr>
+                        <a:t>완전 차단 (T0)</a:t>
+                      </a:r>
+                      <a:endParaRPr lang="en-US" sz="1100" dirty="0">
+                        <a:latin typeface="Arial" charset="0"/>
+                        <a:ea typeface="Arial" charset="0"/>
+                        <a:cs typeface="Arial" charset="0"/>
+                      </a:endParaRPr>
+                    </a:p>
+                  </a:txBody>
+                  <a:tcPr marL="91440" marR="91440" marT="45720" marB="45720" anchor="ctr">
+                    <a:lnL w="9525" cap="flat" cmpd="sng" algn="ctr">
+                      <a:solidFill>
+                        <a:srgbClr val="E2E8F0"/>
+                      </a:solidFill>
+                      <a:prstDash val="solid"/>
+                      <a:round/>
+                      <a:headEnd type="none" w="med" len="med"/>
+                      <a:tailEnd type="none" w="med" len="med"/>
+                    </a:lnL>
+                    <a:lnR w="9525" cap="flat" cmpd="sng" algn="ctr">
+                      <a:solidFill>
+                        <a:srgbClr val="E2E8F0"/>
+                      </a:solidFill>
+                      <a:prstDash val="solid"/>
+                      <a:round/>
+                      <a:headEnd type="none" w="med" len="med"/>
+                      <a:tailEnd type="none" w="med" len="med"/>
+                    </a:lnR>
+                    <a:lnT w="9525" cap="flat" cmpd="sng" algn="ctr">
+                      <a:solidFill>
+                        <a:srgbClr val="E2E8F0"/>
+                      </a:solidFill>
+                      <a:prstDash val="solid"/>
+                      <a:round/>
+                      <a:headEnd type="none" w="med" len="med"/>
+                      <a:tailEnd type="none" w="med" len="med"/>
+                    </a:lnT>
+                    <a:lnB w="9525" cap="flat" cmpd="sng" algn="ctr">
+                      <a:solidFill>
+                        <a:srgbClr val="E2E8F0"/>
+                      </a:solidFill>
+                      <a:prstDash val="solid"/>
+                      <a:round/>
+                      <a:headEnd type="none" w="med" len="med"/>
+                      <a:tailEnd type="none" w="med" len="med"/>
+                    </a:lnB>
+                    <a:solidFill>
+                      <a:srgbClr val="FFFFFF"/>
+                    </a:solidFill>
+                  </a:tcPr>
+                </a:tc>
+                <a:tc>
+                  <a:txBody>
+                    <a:bodyPr/>
+                    <a:lstStyle/>
+                    <a:p>
+                      <a:pPr algn="ctr" indent="0" marL="0">
+                        <a:buNone/>
+                      </a:pPr>
+                      <a:r>
+                        <a:rPr lang="en-US" sz="1100" dirty="0">
+                          <a:solidFill>
+                            <a:srgbClr val="2E8B57"/>
+                          </a:solidFill>
+                          <a:latin typeface="Arial" pitchFamily="34" charset="0"/>
+                          <a:ea typeface="Arial" pitchFamily="34" charset="-122"/>
+                          <a:cs typeface="Arial" pitchFamily="34" charset="-120"/>
+                        </a:rPr>
+                        <a:t>0.933</a:t>
+                      </a:r>
+                      <a:endParaRPr lang="en-US" sz="1100" dirty="0">
+                        <a:latin typeface="Arial" charset="0"/>
+                        <a:ea typeface="Arial" charset="0"/>
+                        <a:cs typeface="Arial" charset="0"/>
+                      </a:endParaRPr>
+                    </a:p>
+                  </a:txBody>
+                  <a:tcPr marL="91440" marR="91440" marT="45720" marB="45720" anchor="ctr">
+                    <a:lnL w="9525" cap="flat" cmpd="sng" algn="ctr">
+                      <a:solidFill>
+                        <a:srgbClr val="E2E8F0"/>
+                      </a:solidFill>
+                      <a:prstDash val="solid"/>
+                      <a:round/>
+                      <a:headEnd type="none" w="med" len="med"/>
+                      <a:tailEnd type="none" w="med" len="med"/>
+                    </a:lnL>
+                    <a:lnR w="9525" cap="flat" cmpd="sng" algn="ctr">
+                      <a:solidFill>
+                        <a:srgbClr val="E2E8F0"/>
+                      </a:solidFill>
+                      <a:prstDash val="solid"/>
+                      <a:round/>
+                      <a:headEnd type="none" w="med" len="med"/>
+                      <a:tailEnd type="none" w="med" len="med"/>
+                    </a:lnR>
+                    <a:lnT w="9525" cap="flat" cmpd="sng" algn="ctr">
+                      <a:solidFill>
+                        <a:srgbClr val="E2E8F0"/>
+                      </a:solidFill>
+                      <a:prstDash val="solid"/>
+                      <a:round/>
+                      <a:headEnd type="none" w="med" len="med"/>
+                      <a:tailEnd type="none" w="med" len="med"/>
+                    </a:lnT>
+                    <a:lnB w="9525" cap="flat" cmpd="sng" algn="ctr">
+                      <a:solidFill>
+                        <a:srgbClr val="E2E8F0"/>
+                      </a:solidFill>
+                      <a:prstDash val="solid"/>
+                      <a:round/>
+                      <a:headEnd type="none" w="med" len="med"/>
+                      <a:tailEnd type="none" w="med" len="med"/>
+                    </a:lnB>
+                    <a:solidFill>
+                      <a:srgbClr val="FFFFFF"/>
+                    </a:solidFill>
+                  </a:tcPr>
+                </a:tc>
+                <a:tc>
+                  <a:txBody>
+                    <a:bodyPr/>
+                    <a:lstStyle/>
+                    <a:p>
+                      <a:pPr algn="ctr" indent="0" marL="0">
+                        <a:buNone/>
+                      </a:pPr>
+                      <a:r>
+                        <a:rPr lang="en-US" sz="1100" dirty="0">
+                          <a:solidFill>
+                            <a:srgbClr val="2E8B57"/>
+                          </a:solidFill>
+                          <a:latin typeface="Arial" pitchFamily="34" charset="0"/>
+                          <a:ea typeface="Arial" pitchFamily="34" charset="-122"/>
+                          <a:cs typeface="Arial" pitchFamily="34" charset="-120"/>
+                        </a:rPr>
+                        <a:t>0.953</a:t>
+                      </a:r>
+                      <a:endParaRPr lang="en-US" sz="1100" dirty="0">
+                        <a:latin typeface="Arial" charset="0"/>
+                        <a:ea typeface="Arial" charset="0"/>
+                        <a:cs typeface="Arial" charset="0"/>
+                      </a:endParaRPr>
+                    </a:p>
+                  </a:txBody>
+                  <a:tcPr marL="91440" marR="91440" marT="45720" marB="45720" anchor="ctr">
+                    <a:lnL w="9525" cap="flat" cmpd="sng" algn="ctr">
+                      <a:solidFill>
+                        <a:srgbClr val="E2E8F0"/>
+                      </a:solidFill>
+                      <a:prstDash val="solid"/>
+                      <a:round/>
+                      <a:headEnd type="none" w="med" len="med"/>
+                      <a:tailEnd type="none" w="med" len="med"/>
+                    </a:lnL>
+                    <a:lnR w="9525" cap="flat" cmpd="sng" algn="ctr">
+                      <a:solidFill>
+                        <a:srgbClr val="E2E8F0"/>
+                      </a:solidFill>
+                      <a:prstDash val="solid"/>
+                      <a:round/>
+                      <a:headEnd type="none" w="med" len="med"/>
+                      <a:tailEnd type="none" w="med" len="med"/>
+                    </a:lnR>
+                    <a:lnT w="9525" cap="flat" cmpd="sng" algn="ctr">
+                      <a:solidFill>
+                        <a:srgbClr val="E2E8F0"/>
+                      </a:solidFill>
+                      <a:prstDash val="solid"/>
+                      <a:round/>
+                      <a:headEnd type="none" w="med" len="med"/>
+                      <a:tailEnd type="none" w="med" len="med"/>
+                    </a:lnT>
+                    <a:lnB w="9525" cap="flat" cmpd="sng" algn="ctr">
+                      <a:solidFill>
+                        <a:srgbClr val="E2E8F0"/>
+                      </a:solidFill>
+                      <a:prstDash val="solid"/>
+                      <a:round/>
+                      <a:headEnd type="none" w="med" len="med"/>
+                      <a:tailEnd type="none" w="med" len="med"/>
+                    </a:lnB>
+                    <a:solidFill>
+                      <a:srgbClr val="FFFFFF"/>
+                    </a:solidFill>
+                  </a:tcPr>
+                </a:tc>
+                <a:tc>
+                  <a:txBody>
+                    <a:bodyPr/>
+                    <a:lstStyle/>
+                    <a:p>
+                      <a:pPr algn="ctr" indent="0" marL="0">
+                        <a:buNone/>
+                      </a:pPr>
+                      <a:r>
+                        <a:rPr lang="en-US" sz="1100" dirty="0">
+                          <a:solidFill>
+                            <a:srgbClr val="D62728"/>
+                          </a:solidFill>
+                          <a:latin typeface="Arial" pitchFamily="34" charset="0"/>
+                          <a:ea typeface="Arial" pitchFamily="34" charset="-122"/>
+                          <a:cs typeface="Arial" pitchFamily="34" charset="-120"/>
+                        </a:rPr>
+                        <a:t>0.720</a:t>
+                      </a:r>
+                      <a:endParaRPr lang="en-US" sz="1100" dirty="0">
+                        <a:latin typeface="Arial" charset="0"/>
+                        <a:ea typeface="Arial" charset="0"/>
+                        <a:cs typeface="Arial" charset="0"/>
+                      </a:endParaRPr>
+                    </a:p>
+                  </a:txBody>
+                  <a:tcPr marL="91440" marR="91440" marT="45720" marB="45720" anchor="ctr">
+                    <a:lnL w="9525" cap="flat" cmpd="sng" algn="ctr">
+                      <a:solidFill>
+                        <a:srgbClr val="E2E8F0"/>
+                      </a:solidFill>
+                      <a:prstDash val="solid"/>
+                      <a:round/>
+                      <a:headEnd type="none" w="med" len="med"/>
+                      <a:tailEnd type="none" w="med" len="med"/>
+                    </a:lnL>
+                    <a:lnR w="9525" cap="flat" cmpd="sng" algn="ctr">
+                      <a:solidFill>
+                        <a:srgbClr val="E2E8F0"/>
+                      </a:solidFill>
+                      <a:prstDash val="solid"/>
+                      <a:round/>
+                      <a:headEnd type="none" w="med" len="med"/>
+                      <a:tailEnd type="none" w="med" len="med"/>
+                    </a:lnR>
+                    <a:lnT w="9525" cap="flat" cmpd="sng" algn="ctr">
+                      <a:solidFill>
+                        <a:srgbClr val="E2E8F0"/>
+                      </a:solidFill>
+                      <a:prstDash val="solid"/>
+                      <a:round/>
+                      <a:headEnd type="none" w="med" len="med"/>
+                      <a:tailEnd type="none" w="med" len="med"/>
+                    </a:lnT>
+                    <a:lnB w="9525" cap="flat" cmpd="sng" algn="ctr">
+                      <a:solidFill>
+                        <a:srgbClr val="E2E8F0"/>
+                      </a:solidFill>
+                      <a:prstDash val="solid"/>
+                      <a:round/>
+                      <a:headEnd type="none" w="med" len="med"/>
+                      <a:tailEnd type="none" w="med" len="med"/>
+                    </a:lnB>
+                    <a:solidFill>
+                      <a:srgbClr val="FFFFFF"/>
+                    </a:solidFill>
+                  </a:tcPr>
+                </a:tc>
+                <a:tc>
+                  <a:txBody>
+                    <a:bodyPr/>
+                    <a:lstStyle/>
+                    <a:p>
+                      <a:pPr algn="ctr" indent="0" marL="0">
+                        <a:buNone/>
+                      </a:pPr>
+                      <a:r>
+                        <a:rPr lang="en-US" sz="1100" dirty="0">
+                          <a:solidFill>
+                            <a:srgbClr val="D62728"/>
+                          </a:solidFill>
+                          <a:latin typeface="Arial" pitchFamily="34" charset="0"/>
+                          <a:ea typeface="Arial" pitchFamily="34" charset="-122"/>
+                          <a:cs typeface="Arial" pitchFamily="34" charset="-120"/>
+                        </a:rPr>
+                        <a:t>0.773</a:t>
+                      </a:r>
+                      <a:endParaRPr lang="en-US" sz="1100" dirty="0">
+                        <a:latin typeface="Arial" charset="0"/>
+                        <a:ea typeface="Arial" charset="0"/>
+                        <a:cs typeface="Arial" charset="0"/>
+                      </a:endParaRPr>
+                    </a:p>
+                  </a:txBody>
+                  <a:tcPr marL="91440" marR="91440" marT="45720" marB="45720" anchor="ctr">
+                    <a:lnL w="9525" cap="flat" cmpd="sng" algn="ctr">
+                      <a:solidFill>
+                        <a:srgbClr val="E2E8F0"/>
+                      </a:solidFill>
+                      <a:prstDash val="solid"/>
+                      <a:round/>
+                      <a:headEnd type="none" w="med" len="med"/>
+                      <a:tailEnd type="none" w="med" len="med"/>
+                    </a:lnL>
+                    <a:lnR w="9525" cap="flat" cmpd="sng" algn="ctr">
+                      <a:solidFill>
+                        <a:srgbClr val="E2E8F0"/>
+                      </a:solidFill>
+                      <a:prstDash val="solid"/>
+                      <a:round/>
+                      <a:headEnd type="none" w="med" len="med"/>
+                      <a:tailEnd type="none" w="med" len="med"/>
+                    </a:lnR>
+                    <a:lnT w="9525" cap="flat" cmpd="sng" algn="ctr">
+                      <a:solidFill>
+                        <a:srgbClr val="E2E8F0"/>
+                      </a:solidFill>
+                      <a:prstDash val="solid"/>
+                      <a:round/>
+                      <a:headEnd type="none" w="med" len="med"/>
+                      <a:tailEnd type="none" w="med" len="med"/>
+                    </a:lnT>
+                    <a:lnB w="9525" cap="flat" cmpd="sng" algn="ctr">
+                      <a:solidFill>
+                        <a:srgbClr val="E2E8F0"/>
+                      </a:solidFill>
+                      <a:prstDash val="solid"/>
+                      <a:round/>
+                      <a:headEnd type="none" w="med" len="med"/>
+                      <a:tailEnd type="none" w="med" len="med"/>
+                    </a:lnB>
+                    <a:solidFill>
+                      <a:srgbClr val="FFFFFF"/>
+                    </a:solidFill>
+                  </a:tcPr>
+                </a:tc>
+                <a:tc>
+                  <a:txBody>
+                    <a:bodyPr/>
+                    <a:lstStyle/>
+                    <a:p>
+                      <a:pPr algn="ctr" indent="0" marL="0">
+                        <a:buNone/>
+                      </a:pPr>
+                      <a:r>
+                        <a:rPr lang="en-US" sz="1100" b="1" dirty="0">
+                          <a:solidFill>
+                            <a:srgbClr val="1F3B57"/>
+                          </a:solidFill>
+                          <a:latin typeface="Arial" pitchFamily="34" charset="0"/>
+                          <a:ea typeface="Arial" pitchFamily="34" charset="-122"/>
+                          <a:cs typeface="Arial" pitchFamily="34" charset="-120"/>
+                        </a:rPr>
+                        <a:t>0.845</a:t>
+                      </a:r>
+                      <a:endParaRPr lang="en-US" sz="1100" dirty="0">
+                        <a:latin typeface="Arial" charset="0"/>
+                        <a:ea typeface="Arial" charset="0"/>
+                        <a:cs typeface="Arial" charset="0"/>
+                      </a:endParaRPr>
+                    </a:p>
+                  </a:txBody>
+                  <a:tcPr marL="91440" marR="91440" marT="45720" marB="45720" anchor="ctr">
+                    <a:lnL w="9525" cap="flat" cmpd="sng" algn="ctr">
+                      <a:solidFill>
+                        <a:srgbClr val="E2E8F0"/>
+                      </a:solidFill>
+                      <a:prstDash val="solid"/>
+                      <a:round/>
+                      <a:headEnd type="none" w="med" len="med"/>
+                      <a:tailEnd type="none" w="med" len="med"/>
+                    </a:lnL>
+                    <a:lnR w="9525" cap="flat" cmpd="sng" algn="ctr">
+                      <a:solidFill>
+                        <a:srgbClr val="E2E8F0"/>
+                      </a:solidFill>
+                      <a:prstDash val="solid"/>
+                      <a:round/>
+                      <a:headEnd type="none" w="med" len="med"/>
+                      <a:tailEnd type="none" w="med" len="med"/>
+                    </a:lnR>
+                    <a:lnT w="9525" cap="flat" cmpd="sng" algn="ctr">
+                      <a:solidFill>
+                        <a:srgbClr val="E2E8F0"/>
+                      </a:solidFill>
+                      <a:prstDash val="solid"/>
+                      <a:round/>
+                      <a:headEnd type="none" w="med" len="med"/>
+                      <a:tailEnd type="none" w="med" len="med"/>
+                    </a:lnT>
+                    <a:lnB w="9525" cap="flat" cmpd="sng" algn="ctr">
+                      <a:solidFill>
+                        <a:srgbClr val="E2E8F0"/>
+                      </a:solidFill>
+                      <a:prstDash val="solid"/>
+                      <a:round/>
+                      <a:headEnd type="none" w="med" len="med"/>
+                      <a:tailEnd type="none" w="med" len="med"/>
+                    </a:lnB>
+                    <a:solidFill>
+                      <a:srgbClr val="FFFFFF"/>
+                    </a:solidFill>
+                  </a:tcPr>
+                </a:tc>
+                <a:tc>
+                  <a:txBody>
+                    <a:bodyPr/>
+                    <a:lstStyle/>
+                    <a:p>
+                      <a:pPr algn="ctr" indent="0" marL="0">
+                        <a:buNone/>
+                      </a:pPr>
+                      <a:r>
+                        <a:rPr lang="en-US" sz="1100" dirty="0">
+                          <a:solidFill>
+                            <a:srgbClr val="1F3B57"/>
+                          </a:solidFill>
+                          <a:latin typeface="Arial" pitchFamily="34" charset="0"/>
+                          <a:ea typeface="Arial" pitchFamily="34" charset="-122"/>
+                          <a:cs typeface="Arial" pitchFamily="34" charset="-120"/>
+                        </a:rPr>
+                        <a:t>0.402</a:t>
+                      </a:r>
+                      <a:endParaRPr lang="en-US" sz="1100" dirty="0">
+                        <a:latin typeface="Arial" charset="0"/>
+                        <a:ea typeface="Arial" charset="0"/>
+                        <a:cs typeface="Arial" charset="0"/>
+                      </a:endParaRPr>
+                    </a:p>
+                  </a:txBody>
+                  <a:tcPr marL="91440" marR="91440" marT="45720" marB="45720" anchor="ctr">
+                    <a:lnL w="9525" cap="flat" cmpd="sng" algn="ctr">
+                      <a:solidFill>
+                        <a:srgbClr val="E2E8F0"/>
+                      </a:solidFill>
+                      <a:prstDash val="solid"/>
+                      <a:round/>
+                      <a:headEnd type="none" w="med" len="med"/>
+                      <a:tailEnd type="none" w="med" len="med"/>
+                    </a:lnL>
+                    <a:lnR w="9525" cap="flat" cmpd="sng" algn="ctr">
+                      <a:solidFill>
+                        <a:srgbClr val="E2E8F0"/>
+                      </a:solidFill>
+                      <a:prstDash val="solid"/>
+                      <a:round/>
+                      <a:headEnd type="none" w="med" len="med"/>
+                      <a:tailEnd type="none" w="med" len="med"/>
+                    </a:lnR>
+                    <a:lnT w="9525" cap="flat" cmpd="sng" algn="ctr">
+                      <a:solidFill>
+                        <a:srgbClr val="E2E8F0"/>
+                      </a:solidFill>
+                      <a:prstDash val="solid"/>
+                      <a:round/>
+                      <a:headEnd type="none" w="med" len="med"/>
+                      <a:tailEnd type="none" w="med" len="med"/>
+                    </a:lnT>
+                    <a:lnB w="9525" cap="flat" cmpd="sng" algn="ctr">
+                      <a:solidFill>
+                        <a:srgbClr val="E2E8F0"/>
+                      </a:solidFill>
+                      <a:prstDash val="solid"/>
+                      <a:round/>
+                      <a:headEnd type="none" w="med" len="med"/>
+                      <a:tailEnd type="none" w="med" len="med"/>
+                    </a:lnB>
+                    <a:solidFill>
+                      <a:srgbClr val="FFFFFF"/>
+                    </a:solidFill>
+                  </a:tcPr>
+                </a:tc>
+              </a:tr>
+              <a:tr h="402336">
+                <a:tc>
+                  <a:txBody>
+                    <a:bodyPr/>
+                    <a:lstStyle/>
+                    <a:p>
+                      <a:pPr algn="ctr" indent="0" marL="0">
+                        <a:buNone/>
+                      </a:pPr>
+                      <a:r>
+                        <a:rPr lang="en-US" sz="1100" b="1" dirty="0">
+                          <a:solidFill>
+                            <a:srgbClr val="1F3B57"/>
+                          </a:solidFill>
+                          <a:latin typeface="Arial" pitchFamily="34" charset="0"/>
+                          <a:ea typeface="Arial" pitchFamily="34" charset="-122"/>
+                          <a:cs typeface="Arial" pitchFamily="34" charset="-120"/>
+                        </a:rPr>
+                        <a:t>16층부터 차단</a:t>
+                      </a:r>
+                      <a:endParaRPr lang="en-US" sz="1100" dirty="0">
+                        <a:latin typeface="Arial" charset="0"/>
+                        <a:ea typeface="Arial" charset="0"/>
+                        <a:cs typeface="Arial" charset="0"/>
+                      </a:endParaRPr>
+                    </a:p>
+                  </a:txBody>
+                  <a:tcPr marL="91440" marR="91440" marT="45720" marB="45720" anchor="ctr">
+                    <a:lnL w="9525" cap="flat" cmpd="sng" algn="ctr">
+                      <a:solidFill>
+                        <a:srgbClr val="E2E8F0"/>
+                      </a:solidFill>
+                      <a:prstDash val="solid"/>
+                      <a:round/>
+                      <a:headEnd type="none" w="med" len="med"/>
+                      <a:tailEnd type="none" w="med" len="med"/>
+                    </a:lnL>
+                    <a:lnR w="9525" cap="flat" cmpd="sng" algn="ctr">
+                      <a:solidFill>
+                        <a:srgbClr val="E2E8F0"/>
+                      </a:solidFill>
+                      <a:prstDash val="solid"/>
+                      <a:round/>
+                      <a:headEnd type="none" w="med" len="med"/>
+                      <a:tailEnd type="none" w="med" len="med"/>
+                    </a:lnR>
+                    <a:lnT w="9525" cap="flat" cmpd="sng" algn="ctr">
+                      <a:solidFill>
+                        <a:srgbClr val="E2E8F0"/>
+                      </a:solidFill>
+                      <a:prstDash val="solid"/>
+                      <a:round/>
+                      <a:headEnd type="none" w="med" len="med"/>
+                      <a:tailEnd type="none" w="med" len="med"/>
+                    </a:lnT>
+                    <a:lnB w="9525" cap="flat" cmpd="sng" algn="ctr">
+                      <a:solidFill>
+                        <a:srgbClr val="E2E8F0"/>
+                      </a:solidFill>
+                      <a:prstDash val="solid"/>
+                      <a:round/>
+                      <a:headEnd type="none" w="med" len="med"/>
+                      <a:tailEnd type="none" w="med" len="med"/>
+                    </a:lnB>
+                    <a:solidFill>
+                      <a:srgbClr val="FFFFFF"/>
+                    </a:solidFill>
+                  </a:tcPr>
+                </a:tc>
+                <a:tc>
+                  <a:txBody>
+                    <a:bodyPr/>
+                    <a:lstStyle/>
+                    <a:p>
+                      <a:pPr algn="ctr" indent="0" marL="0">
+                        <a:buNone/>
+                      </a:pPr>
+                      <a:r>
+                        <a:rPr lang="en-US" sz="1100" dirty="0">
+                          <a:solidFill>
+                            <a:srgbClr val="2E8B57"/>
+                          </a:solidFill>
+                          <a:latin typeface="Arial" pitchFamily="34" charset="0"/>
+                          <a:ea typeface="Arial" pitchFamily="34" charset="-122"/>
+                          <a:cs typeface="Arial" pitchFamily="34" charset="-120"/>
+                        </a:rPr>
+                        <a:t>0.933</a:t>
+                      </a:r>
+                      <a:endParaRPr lang="en-US" sz="1100" dirty="0">
+                        <a:latin typeface="Arial" charset="0"/>
+                        <a:ea typeface="Arial" charset="0"/>
+                        <a:cs typeface="Arial" charset="0"/>
+                      </a:endParaRPr>
+                    </a:p>
+                  </a:txBody>
+                  <a:tcPr marL="91440" marR="91440" marT="45720" marB="45720" anchor="ctr">
+                    <a:lnL w="9525" cap="flat" cmpd="sng" algn="ctr">
+                      <a:solidFill>
+                        <a:srgbClr val="E2E8F0"/>
+                      </a:solidFill>
+                      <a:prstDash val="solid"/>
+                      <a:round/>
+                      <a:headEnd type="none" w="med" len="med"/>
+                      <a:tailEnd type="none" w="med" len="med"/>
+                    </a:lnL>
+                    <a:lnR w="9525" cap="flat" cmpd="sng" algn="ctr">
+                      <a:solidFill>
+                        <a:srgbClr val="E2E8F0"/>
+                      </a:solidFill>
+                      <a:prstDash val="solid"/>
+                      <a:round/>
+                      <a:headEnd type="none" w="med" len="med"/>
+                      <a:tailEnd type="none" w="med" len="med"/>
+                    </a:lnR>
+                    <a:lnT w="9525" cap="flat" cmpd="sng" algn="ctr">
+                      <a:solidFill>
+                        <a:srgbClr val="E2E8F0"/>
+                      </a:solidFill>
+                      <a:prstDash val="solid"/>
+                      <a:round/>
+                      <a:headEnd type="none" w="med" len="med"/>
+                      <a:tailEnd type="none" w="med" len="med"/>
+                    </a:lnT>
+                    <a:lnB w="9525" cap="flat" cmpd="sng" algn="ctr">
+                      <a:solidFill>
+                        <a:srgbClr val="E2E8F0"/>
+                      </a:solidFill>
+                      <a:prstDash val="solid"/>
+                      <a:round/>
+                      <a:headEnd type="none" w="med" len="med"/>
+                      <a:tailEnd type="none" w="med" len="med"/>
+                    </a:lnB>
+                    <a:solidFill>
+                      <a:srgbClr val="FFFFFF"/>
+                    </a:solidFill>
+                  </a:tcPr>
+                </a:tc>
+                <a:tc>
+                  <a:txBody>
+                    <a:bodyPr/>
+                    <a:lstStyle/>
+                    <a:p>
+                      <a:pPr algn="ctr" indent="0" marL="0">
+                        <a:buNone/>
+                      </a:pPr>
+                      <a:r>
+                        <a:rPr lang="en-US" sz="1100" dirty="0">
+                          <a:solidFill>
+                            <a:srgbClr val="2E8B57"/>
+                          </a:solidFill>
+                          <a:latin typeface="Arial" pitchFamily="34" charset="0"/>
+                          <a:ea typeface="Arial" pitchFamily="34" charset="-122"/>
+                          <a:cs typeface="Arial" pitchFamily="34" charset="-120"/>
+                        </a:rPr>
+                        <a:t>0.967</a:t>
+                      </a:r>
+                      <a:endParaRPr lang="en-US" sz="1100" dirty="0">
+                        <a:latin typeface="Arial" charset="0"/>
+                        <a:ea typeface="Arial" charset="0"/>
+                        <a:cs typeface="Arial" charset="0"/>
+                      </a:endParaRPr>
+                    </a:p>
+                  </a:txBody>
+                  <a:tcPr marL="91440" marR="91440" marT="45720" marB="45720" anchor="ctr">
+                    <a:lnL w="9525" cap="flat" cmpd="sng" algn="ctr">
+                      <a:solidFill>
+                        <a:srgbClr val="E2E8F0"/>
+                      </a:solidFill>
+                      <a:prstDash val="solid"/>
+                      <a:round/>
+                      <a:headEnd type="none" w="med" len="med"/>
+                      <a:tailEnd type="none" w="med" len="med"/>
+                    </a:lnL>
+                    <a:lnR w="9525" cap="flat" cmpd="sng" algn="ctr">
+                      <a:solidFill>
+                        <a:srgbClr val="E2E8F0"/>
+                      </a:solidFill>
+                      <a:prstDash val="solid"/>
+                      <a:round/>
+                      <a:headEnd type="none" w="med" len="med"/>
+                      <a:tailEnd type="none" w="med" len="med"/>
+                    </a:lnR>
+                    <a:lnT w="9525" cap="flat" cmpd="sng" algn="ctr">
+                      <a:solidFill>
+                        <a:srgbClr val="E2E8F0"/>
+                      </a:solidFill>
+                      <a:prstDash val="solid"/>
+                      <a:round/>
+                      <a:headEnd type="none" w="med" len="med"/>
+                      <a:tailEnd type="none" w="med" len="med"/>
+                    </a:lnT>
+                    <a:lnB w="9525" cap="flat" cmpd="sng" algn="ctr">
+                      <a:solidFill>
+                        <a:srgbClr val="E2E8F0"/>
+                      </a:solidFill>
+                      <a:prstDash val="solid"/>
+                      <a:round/>
+                      <a:headEnd type="none" w="med" len="med"/>
+                      <a:tailEnd type="none" w="med" len="med"/>
+                    </a:lnB>
+                    <a:solidFill>
+                      <a:srgbClr val="FFFFFF"/>
+                    </a:solidFill>
+                  </a:tcPr>
+                </a:tc>
+                <a:tc>
+                  <a:txBody>
+                    <a:bodyPr/>
+                    <a:lstStyle/>
+                    <a:p>
+                      <a:pPr algn="ctr" indent="0" marL="0">
+                        <a:buNone/>
+                      </a:pPr>
+                      <a:r>
+                        <a:rPr lang="en-US" sz="1100" dirty="0">
+                          <a:solidFill>
+                            <a:srgbClr val="D62728"/>
+                          </a:solidFill>
+                          <a:latin typeface="Arial" pitchFamily="34" charset="0"/>
+                          <a:ea typeface="Arial" pitchFamily="34" charset="-122"/>
+                          <a:cs typeface="Arial" pitchFamily="34" charset="-120"/>
+                        </a:rPr>
+                        <a:t>0.627</a:t>
+                      </a:r>
+                      <a:endParaRPr lang="en-US" sz="1100" dirty="0">
+                        <a:latin typeface="Arial" charset="0"/>
+                        <a:ea typeface="Arial" charset="0"/>
+                        <a:cs typeface="Arial" charset="0"/>
+                      </a:endParaRPr>
+                    </a:p>
+                  </a:txBody>
+                  <a:tcPr marL="91440" marR="91440" marT="45720" marB="45720" anchor="ctr">
+                    <a:lnL w="9525" cap="flat" cmpd="sng" algn="ctr">
+                      <a:solidFill>
+                        <a:srgbClr val="E2E8F0"/>
+                      </a:solidFill>
+                      <a:prstDash val="solid"/>
+                      <a:round/>
+                      <a:headEnd type="none" w="med" len="med"/>
+                      <a:tailEnd type="none" w="med" len="med"/>
+                    </a:lnL>
+                    <a:lnR w="9525" cap="flat" cmpd="sng" algn="ctr">
+                      <a:solidFill>
+                        <a:srgbClr val="E2E8F0"/>
+                      </a:solidFill>
+                      <a:prstDash val="solid"/>
+                      <a:round/>
+                      <a:headEnd type="none" w="med" len="med"/>
+                      <a:tailEnd type="none" w="med" len="med"/>
+                    </a:lnR>
+                    <a:lnT w="9525" cap="flat" cmpd="sng" algn="ctr">
+                      <a:solidFill>
+                        <a:srgbClr val="E2E8F0"/>
+                      </a:solidFill>
+                      <a:prstDash val="solid"/>
+                      <a:round/>
+                      <a:headEnd type="none" w="med" len="med"/>
+                      <a:tailEnd type="none" w="med" len="med"/>
+                    </a:lnT>
+                    <a:lnB w="9525" cap="flat" cmpd="sng" algn="ctr">
+                      <a:solidFill>
+                        <a:srgbClr val="E2E8F0"/>
+                      </a:solidFill>
+                      <a:prstDash val="solid"/>
+                      <a:round/>
+                      <a:headEnd type="none" w="med" len="med"/>
+                      <a:tailEnd type="none" w="med" len="med"/>
+                    </a:lnB>
+                    <a:solidFill>
+                      <a:srgbClr val="FFFFFF"/>
+                    </a:solidFill>
+                  </a:tcPr>
+                </a:tc>
+                <a:tc>
+                  <a:txBody>
+                    <a:bodyPr/>
+                    <a:lstStyle/>
+                    <a:p>
+                      <a:pPr algn="ctr" indent="0" marL="0">
+                        <a:buNone/>
+                      </a:pPr>
+                      <a:r>
+                        <a:rPr lang="en-US" sz="1100" dirty="0">
+                          <a:solidFill>
+                            <a:srgbClr val="D62728"/>
+                          </a:solidFill>
+                          <a:latin typeface="Arial" pitchFamily="34" charset="0"/>
+                          <a:ea typeface="Arial" pitchFamily="34" charset="-122"/>
+                          <a:cs typeface="Arial" pitchFamily="34" charset="-120"/>
+                        </a:rPr>
+                        <a:t>0.740</a:t>
+                      </a:r>
+                      <a:endParaRPr lang="en-US" sz="1100" dirty="0">
+                        <a:latin typeface="Arial" charset="0"/>
+                        <a:ea typeface="Arial" charset="0"/>
+                        <a:cs typeface="Arial" charset="0"/>
+                      </a:endParaRPr>
+                    </a:p>
+                  </a:txBody>
+                  <a:tcPr marL="91440" marR="91440" marT="45720" marB="45720" anchor="ctr">
+                    <a:lnL w="9525" cap="flat" cmpd="sng" algn="ctr">
+                      <a:solidFill>
+                        <a:srgbClr val="E2E8F0"/>
+                      </a:solidFill>
+                      <a:prstDash val="solid"/>
+                      <a:round/>
+                      <a:headEnd type="none" w="med" len="med"/>
+                      <a:tailEnd type="none" w="med" len="med"/>
+                    </a:lnL>
+                    <a:lnR w="9525" cap="flat" cmpd="sng" algn="ctr">
+                      <a:solidFill>
+                        <a:srgbClr val="E2E8F0"/>
+                      </a:solidFill>
+                      <a:prstDash val="solid"/>
+                      <a:round/>
+                      <a:headEnd type="none" w="med" len="med"/>
+                      <a:tailEnd type="none" w="med" len="med"/>
+                    </a:lnR>
+                    <a:lnT w="9525" cap="flat" cmpd="sng" algn="ctr">
+                      <a:solidFill>
+                        <a:srgbClr val="E2E8F0"/>
+                      </a:solidFill>
+                      <a:prstDash val="solid"/>
+                      <a:round/>
+                      <a:headEnd type="none" w="med" len="med"/>
+                      <a:tailEnd type="none" w="med" len="med"/>
+                    </a:lnT>
+                    <a:lnB w="9525" cap="flat" cmpd="sng" algn="ctr">
+                      <a:solidFill>
+                        <a:srgbClr val="E2E8F0"/>
+                      </a:solidFill>
+                      <a:prstDash val="solid"/>
+                      <a:round/>
+                      <a:headEnd type="none" w="med" len="med"/>
+                      <a:tailEnd type="none" w="med" len="med"/>
+                    </a:lnB>
+                    <a:solidFill>
+                      <a:srgbClr val="FFFFFF"/>
+                    </a:solidFill>
+                  </a:tcPr>
+                </a:tc>
+                <a:tc>
+                  <a:txBody>
+                    <a:bodyPr/>
+                    <a:lstStyle/>
+                    <a:p>
+                      <a:pPr algn="ctr" indent="0" marL="0">
+                        <a:buNone/>
+                      </a:pPr>
+                      <a:r>
+                        <a:rPr lang="en-US" sz="1100" b="1" dirty="0">
+                          <a:solidFill>
+                            <a:srgbClr val="1F3B57"/>
+                          </a:solidFill>
+                          <a:latin typeface="Arial" pitchFamily="34" charset="0"/>
+                          <a:ea typeface="Arial" pitchFamily="34" charset="-122"/>
+                          <a:cs typeface="Arial" pitchFamily="34" charset="-120"/>
+                        </a:rPr>
+                        <a:t>0.817</a:t>
+                      </a:r>
+                      <a:endParaRPr lang="en-US" sz="1100" dirty="0">
+                        <a:latin typeface="Arial" charset="0"/>
+                        <a:ea typeface="Arial" charset="0"/>
+                        <a:cs typeface="Arial" charset="0"/>
+                      </a:endParaRPr>
+                    </a:p>
+                  </a:txBody>
+                  <a:tcPr marL="91440" marR="91440" marT="45720" marB="45720" anchor="ctr">
+                    <a:lnL w="9525" cap="flat" cmpd="sng" algn="ctr">
+                      <a:solidFill>
+                        <a:srgbClr val="E2E8F0"/>
+                      </a:solidFill>
+                      <a:prstDash val="solid"/>
+                      <a:round/>
+                      <a:headEnd type="none" w="med" len="med"/>
+                      <a:tailEnd type="none" w="med" len="med"/>
+                    </a:lnL>
+                    <a:lnR w="9525" cap="flat" cmpd="sng" algn="ctr">
+                      <a:solidFill>
+                        <a:srgbClr val="E2E8F0"/>
+                      </a:solidFill>
+                      <a:prstDash val="solid"/>
+                      <a:round/>
+                      <a:headEnd type="none" w="med" len="med"/>
+                      <a:tailEnd type="none" w="med" len="med"/>
+                    </a:lnR>
+                    <a:lnT w="9525" cap="flat" cmpd="sng" algn="ctr">
+                      <a:solidFill>
+                        <a:srgbClr val="E2E8F0"/>
+                      </a:solidFill>
+                      <a:prstDash val="solid"/>
+                      <a:round/>
+                      <a:headEnd type="none" w="med" len="med"/>
+                      <a:tailEnd type="none" w="med" len="med"/>
+                    </a:lnT>
+                    <a:lnB w="9525" cap="flat" cmpd="sng" algn="ctr">
+                      <a:solidFill>
+                        <a:srgbClr val="E2E8F0"/>
+                      </a:solidFill>
+                      <a:prstDash val="solid"/>
+                      <a:round/>
+                      <a:headEnd type="none" w="med" len="med"/>
+                      <a:tailEnd type="none" w="med" len="med"/>
+                    </a:lnB>
+                    <a:solidFill>
+                      <a:srgbClr val="FFFFFF"/>
+                    </a:solidFill>
+                  </a:tcPr>
+                </a:tc>
+                <a:tc>
+                  <a:txBody>
+                    <a:bodyPr/>
+                    <a:lstStyle/>
+                    <a:p>
+                      <a:pPr algn="ctr" indent="0" marL="0">
+                        <a:buNone/>
+                      </a:pPr>
+                      <a:r>
+                        <a:rPr lang="en-US" sz="1100" dirty="0">
+                          <a:solidFill>
+                            <a:srgbClr val="1F3B57"/>
+                          </a:solidFill>
+                          <a:latin typeface="Arial" pitchFamily="34" charset="0"/>
+                          <a:ea typeface="Arial" pitchFamily="34" charset="-122"/>
+                          <a:cs typeface="Arial" pitchFamily="34" charset="-120"/>
+                        </a:rPr>
+                        <a:t>0.367</a:t>
+                      </a:r>
+                      <a:endParaRPr lang="en-US" sz="1100" dirty="0">
+                        <a:latin typeface="Arial" charset="0"/>
+                        <a:ea typeface="Arial" charset="0"/>
+                        <a:cs typeface="Arial" charset="0"/>
+                      </a:endParaRPr>
+                    </a:p>
+                  </a:txBody>
+                  <a:tcPr marL="91440" marR="91440" marT="45720" marB="45720" anchor="ctr">
+                    <a:lnL w="9525" cap="flat" cmpd="sng" algn="ctr">
+                      <a:solidFill>
+                        <a:srgbClr val="E2E8F0"/>
+                      </a:solidFill>
+                      <a:prstDash val="solid"/>
+                      <a:round/>
+                      <a:headEnd type="none" w="med" len="med"/>
+                      <a:tailEnd type="none" w="med" len="med"/>
+                    </a:lnL>
+                    <a:lnR w="9525" cap="flat" cmpd="sng" algn="ctr">
+                      <a:solidFill>
+                        <a:srgbClr val="E2E8F0"/>
+                      </a:solidFill>
+                      <a:prstDash val="solid"/>
+                      <a:round/>
+                      <a:headEnd type="none" w="med" len="med"/>
+                      <a:tailEnd type="none" w="med" len="med"/>
+                    </a:lnR>
+                    <a:lnT w="9525" cap="flat" cmpd="sng" algn="ctr">
+                      <a:solidFill>
+                        <a:srgbClr val="E2E8F0"/>
+                      </a:solidFill>
+                      <a:prstDash val="solid"/>
+                      <a:round/>
+                      <a:headEnd type="none" w="med" len="med"/>
+                      <a:tailEnd type="none" w="med" len="med"/>
+                    </a:lnT>
+                    <a:lnB w="9525" cap="flat" cmpd="sng" algn="ctr">
+                      <a:solidFill>
+                        <a:srgbClr val="E2E8F0"/>
+                      </a:solidFill>
+                      <a:prstDash val="solid"/>
+                      <a:round/>
+                      <a:headEnd type="none" w="med" len="med"/>
+                      <a:tailEnd type="none" w="med" len="med"/>
+                    </a:lnB>
+                    <a:solidFill>
+                      <a:srgbClr val="FFFFFF"/>
+                    </a:solidFill>
+                  </a:tcPr>
+                </a:tc>
+              </a:tr>
+            </a:tbl>
+          </a:graphicData>
+        </a:graphic>
+      </p:graphicFrame>
       <p:sp>
         <p:nvSpPr>
           <p:cNvPr id="5" name="Text 2"/>
@@ -18052,8 +20646,8 @@
         </p:nvSpPr>
         <p:spPr>
           <a:xfrm>
-            <a:off x="685800" y="5760720"/>
-            <a:ext cx="10789920" cy="320040"/>
+            <a:off x="502920" y="3977640"/>
+            <a:ext cx="11201400" cy="2103120"/>
           </a:xfrm>
           <a:prstGeom prst="rect">
             <a:avLst/>
@@ -18065,21 +20659,88 @@
           <a:bodyPr wrap="square" lIns="0" tIns="0" rIns="0" bIns="0" rtlCol="0" anchor="ctr"/>
           <a:lstStyle/>
           <a:p>
-            <a:pPr indent="0" marL="0">
-              <a:buNone/>
-            </a:pPr>
-            <a:r>
-              <a:rPr lang="en-US" sz="1050" dirty="0">
-                <a:solidFill>
-                  <a:srgbClr val="6B7280"/>
-                </a:solidFill>
-                <a:latin typeface="Arial" pitchFamily="34" charset="0"/>
-                <a:ea typeface="Arial" pitchFamily="34" charset="-122"/>
-                <a:cs typeface="Arial" pitchFamily="34" charset="-120"/>
-              </a:rPr>
-              <a:t>16개 신호(head)를 평균하면 8층 72.5%(당초 판정 기준 미달 지점) — 단일 신호 선택 시 8층 99.8% (본편 질문③)</a:t>
-            </a:r>
-            <a:endParaRPr lang="en-US" sz="1050" dirty="0"/>
+            <a:pPr marL="342900" indent="-342900">
+              <a:spcAft>
+                <a:spcPts val="700"/>
+              </a:spcAft>
+              <a:buSzPct val="100000"/>
+              <a:buChar char="•"/>
+            </a:pPr>
+            <a:r>
+              <a:rPr lang="en-US" sz="1150" dirty="0">
+                <a:solidFill>
+                  <a:srgbClr val="1F3B57"/>
+                </a:solidFill>
+                <a:latin typeface="Arial" pitchFamily="34" charset="0"/>
+                <a:ea typeface="Arial" pitchFamily="34" charset="-122"/>
+                <a:cs typeface="Arial" pitchFamily="34" charset="-120"/>
+              </a:rPr>
+              <a:t>관찰: 차단하면 정답이 '없다'인 문항군은 전부 오르고(초록), '있다'인 문항군은 전부 내린다(빨강) — 그리고 '있다' 응답률 자체가 감소</a:t>
+            </a:r>
+            <a:endParaRPr lang="en-US" sz="1150" dirty="0"/>
+          </a:p>
+          <a:p>
+            <a:pPr marL="342900" indent="-342900">
+              <a:spcAft>
+                <a:spcPts val="700"/>
+              </a:spcAft>
+              <a:buSzPct val="100000"/>
+              <a:buChar char="•"/>
+            </a:pPr>
+            <a:r>
+              <a:rPr lang="en-US" sz="1150" b="1" dirty="0">
+                <a:solidFill>
+                  <a:srgbClr val="1F3B57"/>
+                </a:solidFill>
+                <a:latin typeface="Arial" pitchFamily="34" charset="0"/>
+                <a:ea typeface="Arial" pitchFamily="34" charset="-122"/>
+                <a:cs typeface="Arial" pitchFamily="34" charset="-120"/>
+              </a:rPr>
+              <a:t>→ 이는 정확도 향상이 아니라 판정 기준이 '없다' 쪽으로 이동한 것. 전체 정답률은 84.0% vs 84.2%로 사실상 동일</a:t>
+            </a:r>
+            <a:endParaRPr lang="en-US" sz="1150" dirty="0"/>
+          </a:p>
+          <a:p>
+            <a:pPr marL="342900" indent="-342900">
+              <a:spcAft>
+                <a:spcPts val="700"/>
+              </a:spcAft>
+              <a:buSzPct val="100000"/>
+              <a:buChar char="•"/>
+            </a:pPr>
+            <a:r>
+              <a:rPr lang="en-US" sz="1150" b="1" dirty="0">
+                <a:solidFill>
+                  <a:srgbClr val="1F3B57"/>
+                </a:solidFill>
+                <a:latin typeface="Arial" pitchFamily="34" charset="0"/>
+                <a:ea typeface="Arial" pitchFamily="34" charset="-122"/>
+                <a:cs typeface="Arial" pitchFamily="34" charset="-120"/>
+              </a:rPr>
+              <a:t>→ 따라서 "단일 이미지보다 정확하다"는 주장은 폐기. 올바른 서술은 "차단이 멀티이미지 손실을 단일 이미지 수준으로 회복시킨다"</a:t>
+            </a:r>
+            <a:endParaRPr lang="en-US" sz="1150" dirty="0"/>
+          </a:p>
+          <a:p>
+            <a:pPr marL="342900" indent="-342900">
+              <a:spcAft>
+                <a:spcPts val="700"/>
+              </a:spcAft>
+              <a:buSzPct val="100000"/>
+              <a:buChar char="•"/>
+            </a:pPr>
+            <a:r>
+              <a:rPr lang="en-US" sz="1150" dirty="0">
+                <a:solidFill>
+                  <a:srgbClr val="1F3B57"/>
+                </a:solidFill>
+                <a:latin typeface="Arial" pitchFamily="34" charset="0"/>
+                <a:ea typeface="Arial" pitchFamily="34" charset="-122"/>
+                <a:cs typeface="Arial" pitchFamily="34" charset="-120"/>
+              </a:rPr>
+              <a:t>단, 본편의 핵심 주장(M → T4)은 무관하게 유효: 같은 layout·같은 프롬프트에서 오염 문항군만 +20%p, 오염 없는 대조군은 −2%p — 기준 이동이면 둘 다 올랐어야 함 (응답률 이동폭 3.8%p로는 20%p 설명 불가)</a:t>
+            </a:r>
+            <a:endParaRPr lang="en-US" sz="1150" dirty="0"/>
           </a:p>
         </p:txBody>
       </p:sp>
@@ -19129,7 +21790,7 @@
                 <a:ea typeface="Arial" pitchFamily="34" charset="-122"/>
                 <a:cs typeface="Arial" pitchFamily="34" charset="-120"/>
               </a:rPr>
-              <a:t>APPENDIX A5</a:t>
+              <a:t>APPENDIX A4</a:t>
             </a:r>
             <a:endParaRPr lang="en-US" sz="1150" dirty="0"/>
           </a:p>
@@ -19168,7 +21829,7 @@
                 <a:ea typeface="Arial" pitchFamily="34" charset="-122"/>
                 <a:cs typeface="Arial" pitchFamily="34" charset="-120"/>
               </a:rPr>
-              <a:t>층별 attention 분포 — 정답 문항 vs 뒤집힌 문항</a:t>
+              <a:t>층별 '관련 이미지' 식별률 — 16개 신호 평균 기준 (n=600)</a:t>
             </a:r>
             <a:endParaRPr lang="en-US" sz="2200" dirty="0"/>
           </a:p>
@@ -19176,7 +21837,7 @@
       </p:sp>
       <p:pic>
         <p:nvPicPr>
-          <p:cNvPr id="4" name="Image 0" descr="/Users/hansangmin/Source-Depth/results/fig2_attention_profile.png">    </p:cNvPr>
+          <p:cNvPr id="4" name="Image 0" descr="/Users/hansangmin/Source-Depth/results/aux_chartA_ident_by_layer.png">    </p:cNvPr>
           <p:cNvPicPr>
             <a:picLocks noChangeAspect="1"/>
           </p:cNvPicPr>
@@ -19190,8 +21851,8 @@
         </p:blipFill>
         <p:spPr>
           <a:xfrm>
-            <a:off x="1737360" y="1691640"/>
-            <a:ext cx="8686800" cy="4828032"/>
+            <a:off x="685800" y="1737360"/>
+            <a:ext cx="10789920" cy="3922776"/>
           </a:xfrm>
           <a:prstGeom prst="rect">
             <a:avLst/>
@@ -19206,8 +21867,8 @@
         </p:nvSpPr>
         <p:spPr>
           <a:xfrm>
-            <a:off x="1737360" y="6446520"/>
-            <a:ext cx="8686800" cy="274320"/>
+            <a:off x="685800" y="5760720"/>
+            <a:ext cx="10789920" cy="320040"/>
           </a:xfrm>
           <a:prstGeom prst="rect">
             <a:avLst/>
@@ -19219,7 +21880,7 @@
           <a:bodyPr wrap="square" lIns="0" tIns="0" rIns="0" bIns="0" rtlCol="0" anchor="ctr"/>
           <a:lstStyle/>
           <a:p>
-            <a:pPr algn="ctr" indent="0" marL="0">
+            <a:pPr indent="0" marL="0">
               <a:buNone/>
             </a:pPr>
             <a:r>
@@ -19231,7 +21892,7 @@
                 <a:ea typeface="Arial" pitchFamily="34" charset="-122"/>
                 <a:cs typeface="Arial" pitchFamily="34" charset="-120"/>
               </a:rPr>
-              <a:t>20층 이후 두 이미지의 참조량이 갈라짐 — 본편 '같은 층 전환' 관찰과 정합</a:t>
+              <a:t>16개 신호(head)를 평균하면 8층 72.5%(당초 판정 기준 미달 지점) — 단일 신호 선택 시 8층 99.8% (본편 질문③)</a:t>
             </a:r>
             <a:endParaRPr lang="en-US" sz="1050" dirty="0"/>
           </a:p>
@@ -19295,7 +21956,7 @@
                 <a:ea typeface="Arial" pitchFamily="34" charset="-122"/>
                 <a:cs typeface="Arial" pitchFamily="34" charset="-120"/>
               </a:rPr>
-              <a:t>APPENDIX A6</a:t>
+              <a:t>APPENDIX A5</a:t>
             </a:r>
             <a:endParaRPr lang="en-US" sz="1150" dirty="0"/>
           </a:p>
@@ -19334,22 +21995,46 @@
                 <a:ea typeface="Arial" pitchFamily="34" charset="-122"/>
                 <a:cs typeface="Arial" pitchFamily="34" charset="-120"/>
               </a:rPr>
-              <a:t>재현성 · 환경 · 한계</a:t>
+              <a:t>층별 attention 분포 — 정답 문항 vs 뒤집힌 문항</a:t>
             </a:r>
             <a:endParaRPr lang="en-US" sz="2200" dirty="0"/>
           </a:p>
         </p:txBody>
       </p:sp>
-      <p:sp>
-        <p:nvSpPr>
-          <p:cNvPr id="4" name="Text 2"/>
-          <p:cNvSpPr/>
-          <p:nvPr/>
-        </p:nvSpPr>
-        <p:spPr>
-          <a:xfrm>
-            <a:off x="640080" y="1828800"/>
-            <a:ext cx="10972800" cy="4206240"/>
+      <p:pic>
+        <p:nvPicPr>
+          <p:cNvPr id="4" name="Image 0" descr="/Users/hansangmin/Source-Depth/results/fig2_attention_profile.png">    </p:cNvPr>
+          <p:cNvPicPr>
+            <a:picLocks noChangeAspect="1"/>
+          </p:cNvPicPr>
+          <p:nvPr/>
+        </p:nvPicPr>
+        <p:blipFill>
+          <a:blip r:embed="rId1"/>
+          <a:stretch>
+            <a:fillRect/>
+          </a:stretch>
+        </p:blipFill>
+        <p:spPr>
+          <a:xfrm>
+            <a:off x="1737360" y="1691640"/>
+            <a:ext cx="8686800" cy="4828032"/>
+          </a:xfrm>
+          <a:prstGeom prst="rect">
+            <a:avLst/>
+          </a:prstGeom>
+        </p:spPr>
+      </p:pic>
+      <p:sp>
+        <p:nvSpPr>
+          <p:cNvPr id="5" name="Text 2"/>
+          <p:cNvSpPr/>
+          <p:nvPr/>
+        </p:nvSpPr>
+        <p:spPr>
+          <a:xfrm>
+            <a:off x="1737360" y="6446520"/>
+            <a:ext cx="8686800" cy="274320"/>
           </a:xfrm>
           <a:prstGeom prst="rect">
             <a:avLst/>
@@ -19361,130 +22046,21 @@
           <a:bodyPr wrap="square" lIns="0" tIns="0" rIns="0" bIns="0" rtlCol="0" anchor="ctr"/>
           <a:lstStyle/>
           <a:p>
-            <a:pPr marL="342900" indent="-342900">
-              <a:spcAft>
-                <a:spcPts val="1400"/>
-              </a:spcAft>
-              <a:buSzPct val="100000"/>
-              <a:buChar char="•"/>
-            </a:pPr>
-            <a:r>
-              <a:rPr lang="en-US" sz="1300" dirty="0">
-                <a:solidFill>
-                  <a:srgbClr val="1F3B57"/>
-                </a:solidFill>
-                <a:latin typeface="Arial" pitchFamily="34" charset="0"/>
-                <a:ea typeface="Arial" pitchFamily="34" charset="-122"/>
-                <a:cs typeface="Arial" pitchFamily="34" charset="-120"/>
-              </a:rPr>
-              <a:t>환경: RTX 3090 24GB × 1 · torch 2.5.1+cu121 · transformers 4.52.3 · Qwen2.5-VL-3B-Instruct (BF16, eager) · 실측 36 layers</a:t>
-            </a:r>
-            <a:endParaRPr lang="en-US" sz="1300" dirty="0"/>
-          </a:p>
-          <a:p>
-            <a:pPr marL="342900" indent="-342900">
-              <a:spcAft>
-                <a:spcPts val="1400"/>
-              </a:spcAft>
-              <a:buSzPct val="100000"/>
-              <a:buChar char="•"/>
-            </a:pPr>
-            <a:r>
-              <a:rPr lang="en-US" sz="1300" dirty="0">
-                <a:solidFill>
-                  <a:srgbClr val="1F3B57"/>
-                </a:solidFill>
-                <a:latin typeface="Arial" pitchFamily="34" charset="0"/>
-                <a:ea typeface="Arial" pitchFamily="34" charset="-122"/>
-                <a:cs typeface="Arial" pitchFamily="34" charset="-120"/>
-              </a:rPr>
-              <a:t>재현성: 난수 고정(seed 42) · 판정 기준 사전 등록(문서 동결) · 전 결과 raw 보존 · 실행 로그·버전 기록</a:t>
-            </a:r>
-            <a:endParaRPr lang="en-US" sz="1300" dirty="0"/>
-          </a:p>
-          <a:p>
-            <a:pPr marL="342900" indent="-342900">
-              <a:spcAft>
-                <a:spcPts val="1400"/>
-              </a:spcAft>
-              <a:buSzPct val="100000"/>
-              <a:buChar char="•"/>
-            </a:pPr>
-            <a:r>
-              <a:rPr lang="en-US" sz="1300" dirty="0">
-                <a:solidFill>
-                  <a:srgbClr val="1F3B57"/>
-                </a:solidFill>
-                <a:latin typeface="Arial" pitchFamily="34" charset="0"/>
-                <a:ea typeface="Arial" pitchFamily="34" charset="-122"/>
-                <a:cs typeface="Arial" pitchFamily="34" charset="-120"/>
-              </a:rPr>
-              <a:t>규모·비용: 본 실험 29분 + 야간 확장 실험 · GPU 1장 · 오류 중단 0건</a:t>
-            </a:r>
-            <a:endParaRPr lang="en-US" sz="1300" dirty="0"/>
-          </a:p>
-          <a:p>
-            <a:pPr marL="342900" indent="-342900">
-              <a:spcAft>
-                <a:spcPts val="1400"/>
-              </a:spcAft>
-              <a:buSzPct val="100000"/>
-              <a:buChar char="•"/>
-            </a:pPr>
-            <a:r>
-              <a:rPr lang="en-US" sz="1300" dirty="0">
-                <a:solidFill>
-                  <a:srgbClr val="1F3B57"/>
-                </a:solidFill>
-                <a:latin typeface="Arial" pitchFamily="34" charset="0"/>
-                <a:ea typeface="Arial" pitchFamily="34" charset="-122"/>
-                <a:cs typeface="Arial" pitchFamily="34" charset="-120"/>
-              </a:rPr>
-              <a:t>동점 처리: Yes/No 확률이 같은 104건(1.7%)은 사전 규정('없다'로 판정)대로 처리</a:t>
-            </a:r>
-            <a:endParaRPr lang="en-US" sz="1300" dirty="0"/>
-          </a:p>
-          <a:p>
-            <a:pPr marL="342900" indent="-342900">
-              <a:spcAft>
-                <a:spcPts val="1400"/>
-              </a:spcAft>
-              <a:buSzPct val="100000"/>
-              <a:buChar char="•"/>
-            </a:pPr>
-            <a:r>
-              <a:rPr lang="en-US" sz="1300" dirty="0">
-                <a:solidFill>
-                  <a:srgbClr val="1F3B57"/>
-                </a:solidFill>
-                <a:latin typeface="Arial" pitchFamily="34" charset="0"/>
-                <a:ea typeface="Arial" pitchFamily="34" charset="-122"/>
-                <a:cs typeface="Arial" pitchFamily="34" charset="-120"/>
-              </a:rPr>
-              <a:t>저장소: github.com/hsmai/Source-Depth (private) — 코드·데이터 명세·문서·판정 기준·raw 결과 전부 버전 관리</a:t>
-            </a:r>
-            <a:endParaRPr lang="en-US" sz="1300" dirty="0"/>
-          </a:p>
-          <a:p>
-            <a:pPr marL="342900" indent="-342900">
-              <a:spcAft>
-                <a:spcPts val="1400"/>
-              </a:spcAft>
-              <a:buSzPct val="100000"/>
-              <a:buChar char="•"/>
-            </a:pPr>
-            <a:r>
-              <a:rPr lang="en-US" sz="1300" b="1" dirty="0">
-                <a:solidFill>
-                  <a:srgbClr val="1F3B57"/>
-                </a:solidFill>
-                <a:latin typeface="Arial" pitchFamily="34" charset="0"/>
-                <a:ea typeface="Arial" pitchFamily="34" charset="-122"/>
-                <a:cs typeface="Arial" pitchFamily="34" charset="-120"/>
-              </a:rPr>
-              <a:t>한계(정직 고지): 정답 이미지 위치 고정(oracle) · 단일 물체 질문 중심 · 3B 단일 모델(7B 재현 진행 중) · 속도는 프로토타입 실측 · COCO 주석 노이즈 36건(6%)</a:t>
-            </a:r>
-            <a:endParaRPr lang="en-US" sz="1300" dirty="0"/>
+            <a:pPr algn="ctr" indent="0" marL="0">
+              <a:buNone/>
+            </a:pPr>
+            <a:r>
+              <a:rPr lang="en-US" sz="1050" dirty="0">
+                <a:solidFill>
+                  <a:srgbClr val="6B7280"/>
+                </a:solidFill>
+                <a:latin typeface="Arial" pitchFamily="34" charset="0"/>
+                <a:ea typeface="Arial" pitchFamily="34" charset="-122"/>
+                <a:cs typeface="Arial" pitchFamily="34" charset="-120"/>
+              </a:rPr>
+              <a:t>20층 이후 두 이미지의 참조량이 갈라짐 — 본편 '같은 층 전환' 관찰과 정합</a:t>
+            </a:r>
+            <a:endParaRPr lang="en-US" sz="1050" dirty="0"/>
           </a:p>
         </p:txBody>
       </p:sp>
@@ -19546,6 +22122,257 @@
                 <a:ea typeface="Arial" pitchFamily="34" charset="-122"/>
                 <a:cs typeface="Arial" pitchFamily="34" charset="-120"/>
               </a:rPr>
+              <a:t>APPENDIX A6</a:t>
+            </a:r>
+            <a:endParaRPr lang="en-US" sz="1150" dirty="0"/>
+          </a:p>
+        </p:txBody>
+      </p:sp>
+      <p:sp>
+        <p:nvSpPr>
+          <p:cNvPr id="3" name="Text 1"/>
+          <p:cNvSpPr/>
+          <p:nvPr/>
+        </p:nvSpPr>
+        <p:spPr>
+          <a:xfrm>
+            <a:off x="502920" y="512064"/>
+            <a:ext cx="11155680" cy="731520"/>
+          </a:xfrm>
+          <a:prstGeom prst="rect">
+            <a:avLst/>
+          </a:prstGeom>
+          <a:noFill/>
+          <a:ln/>
+        </p:spPr>
+        <p:txBody>
+          <a:bodyPr wrap="square" lIns="0" tIns="0" rIns="0" bIns="0" rtlCol="0" anchor="ctr"/>
+          <a:lstStyle/>
+          <a:p>
+            <a:pPr indent="0" marL="0">
+              <a:buNone/>
+            </a:pPr>
+            <a:r>
+              <a:rPr lang="en-US" sz="2200" b="1" dirty="0">
+                <a:solidFill>
+                  <a:srgbClr val="1F3B57"/>
+                </a:solidFill>
+                <a:latin typeface="Arial" pitchFamily="34" charset="0"/>
+                <a:ea typeface="Arial" pitchFamily="34" charset="-122"/>
+                <a:cs typeface="Arial" pitchFamily="34" charset="-120"/>
+              </a:rPr>
+              <a:t>재현성 · 환경 · 한계</a:t>
+            </a:r>
+            <a:endParaRPr lang="en-US" sz="2200" dirty="0"/>
+          </a:p>
+        </p:txBody>
+      </p:sp>
+      <p:sp>
+        <p:nvSpPr>
+          <p:cNvPr id="4" name="Text 2"/>
+          <p:cNvSpPr/>
+          <p:nvPr/>
+        </p:nvSpPr>
+        <p:spPr>
+          <a:xfrm>
+            <a:off x="640080" y="1828800"/>
+            <a:ext cx="10972800" cy="4206240"/>
+          </a:xfrm>
+          <a:prstGeom prst="rect">
+            <a:avLst/>
+          </a:prstGeom>
+          <a:noFill/>
+          <a:ln/>
+        </p:spPr>
+        <p:txBody>
+          <a:bodyPr wrap="square" lIns="0" tIns="0" rIns="0" bIns="0" rtlCol="0" anchor="ctr"/>
+          <a:lstStyle/>
+          <a:p>
+            <a:pPr marL="342900" indent="-342900">
+              <a:spcAft>
+                <a:spcPts val="1400"/>
+              </a:spcAft>
+              <a:buSzPct val="100000"/>
+              <a:buChar char="•"/>
+            </a:pPr>
+            <a:r>
+              <a:rPr lang="en-US" sz="1300" dirty="0">
+                <a:solidFill>
+                  <a:srgbClr val="1F3B57"/>
+                </a:solidFill>
+                <a:latin typeface="Arial" pitchFamily="34" charset="0"/>
+                <a:ea typeface="Arial" pitchFamily="34" charset="-122"/>
+                <a:cs typeface="Arial" pitchFamily="34" charset="-120"/>
+              </a:rPr>
+              <a:t>환경: RTX 3090 24GB × 1 · torch 2.5.1+cu121 · transformers 4.52.3 · Qwen2.5-VL-3B-Instruct (BF16, eager) · 실측 36 layers</a:t>
+            </a:r>
+            <a:endParaRPr lang="en-US" sz="1300" dirty="0"/>
+          </a:p>
+          <a:p>
+            <a:pPr marL="342900" indent="-342900">
+              <a:spcAft>
+                <a:spcPts val="1400"/>
+              </a:spcAft>
+              <a:buSzPct val="100000"/>
+              <a:buChar char="•"/>
+            </a:pPr>
+            <a:r>
+              <a:rPr lang="en-US" sz="1300" dirty="0">
+                <a:solidFill>
+                  <a:srgbClr val="1F3B57"/>
+                </a:solidFill>
+                <a:latin typeface="Arial" pitchFamily="34" charset="0"/>
+                <a:ea typeface="Arial" pitchFamily="34" charset="-122"/>
+                <a:cs typeface="Arial" pitchFamily="34" charset="-120"/>
+              </a:rPr>
+              <a:t>재현성: 난수 고정(seed 42) · 판정 기준 사전 등록(문서 동결) · 전 결과 raw 보존 · 실행 로그·버전 기록</a:t>
+            </a:r>
+            <a:endParaRPr lang="en-US" sz="1300" dirty="0"/>
+          </a:p>
+          <a:p>
+            <a:pPr marL="342900" indent="-342900">
+              <a:spcAft>
+                <a:spcPts val="1400"/>
+              </a:spcAft>
+              <a:buSzPct val="100000"/>
+              <a:buChar char="•"/>
+            </a:pPr>
+            <a:r>
+              <a:rPr lang="en-US" sz="1300" dirty="0">
+                <a:solidFill>
+                  <a:srgbClr val="1F3B57"/>
+                </a:solidFill>
+                <a:latin typeface="Arial" pitchFamily="34" charset="0"/>
+                <a:ea typeface="Arial" pitchFamily="34" charset="-122"/>
+                <a:cs typeface="Arial" pitchFamily="34" charset="-120"/>
+              </a:rPr>
+              <a:t>규모·비용: 본 실험 29분 + 야간 확장 실험 · GPU 1장 · 오류 중단 0건</a:t>
+            </a:r>
+            <a:endParaRPr lang="en-US" sz="1300" dirty="0"/>
+          </a:p>
+          <a:p>
+            <a:pPr marL="342900" indent="-342900">
+              <a:spcAft>
+                <a:spcPts val="1400"/>
+              </a:spcAft>
+              <a:buSzPct val="100000"/>
+              <a:buChar char="•"/>
+            </a:pPr>
+            <a:r>
+              <a:rPr lang="en-US" sz="1300" dirty="0">
+                <a:solidFill>
+                  <a:srgbClr val="1F3B57"/>
+                </a:solidFill>
+                <a:latin typeface="Arial" pitchFamily="34" charset="0"/>
+                <a:ea typeface="Arial" pitchFamily="34" charset="-122"/>
+                <a:cs typeface="Arial" pitchFamily="34" charset="-120"/>
+              </a:rPr>
+              <a:t>동점 처리: Yes/No 확률이 같은 104건(1.7%)은 사전 규정('없다'로 판정)대로 처리</a:t>
+            </a:r>
+            <a:endParaRPr lang="en-US" sz="1300" dirty="0"/>
+          </a:p>
+          <a:p>
+            <a:pPr marL="342900" indent="-342900">
+              <a:spcAft>
+                <a:spcPts val="1400"/>
+              </a:spcAft>
+              <a:buSzPct val="100000"/>
+              <a:buChar char="•"/>
+            </a:pPr>
+            <a:r>
+              <a:rPr lang="en-US" sz="1300" dirty="0">
+                <a:solidFill>
+                  <a:srgbClr val="1F3B57"/>
+                </a:solidFill>
+                <a:latin typeface="Arial" pitchFamily="34" charset="0"/>
+                <a:ea typeface="Arial" pitchFamily="34" charset="-122"/>
+                <a:cs typeface="Arial" pitchFamily="34" charset="-120"/>
+              </a:rPr>
+              <a:t>저장소: github.com/hsmai/Source-Depth (private) — 코드·데이터 명세·문서·판정 기준·raw 결과 전부 버전 관리</a:t>
+            </a:r>
+            <a:endParaRPr lang="en-US" sz="1300" dirty="0"/>
+          </a:p>
+          <a:p>
+            <a:pPr marL="342900" indent="-342900">
+              <a:spcAft>
+                <a:spcPts val="1400"/>
+              </a:spcAft>
+              <a:buSzPct val="100000"/>
+              <a:buChar char="•"/>
+            </a:pPr>
+            <a:r>
+              <a:rPr lang="en-US" sz="1300" b="1" dirty="0">
+                <a:solidFill>
+                  <a:srgbClr val="1F3B57"/>
+                </a:solidFill>
+                <a:latin typeface="Arial" pitchFamily="34" charset="0"/>
+                <a:ea typeface="Arial" pitchFamily="34" charset="-122"/>
+                <a:cs typeface="Arial" pitchFamily="34" charset="-120"/>
+              </a:rPr>
+              <a:t>한계(정직 고지): 정답 이미지 위치 고정(oracle) · 단일 물체 질문 중심 · 3B 단일 모델(7B 재현 진행 중) · 속도는 프로토타입 실측 · COCO 주석 노이즈 36건(6%)</a:t>
+            </a:r>
+            <a:endParaRPr lang="en-US" sz="1300" dirty="0"/>
+          </a:p>
+        </p:txBody>
+      </p:sp>
+    </p:spTree>
+  </p:cSld>
+  <p:clrMapOvr>
+    <a:masterClrMapping/>
+  </p:clrMapOvr>
+</p:sld>
+</file>
+
+<file path=ppt/slides/slide23.xml><?xml version="1.0" encoding="utf-8"?>
+<p:sld xmlns:a="http://schemas.openxmlformats.org/drawingml/2006/main" xmlns:r="http://schemas.openxmlformats.org/officeDocument/2006/relationships" xmlns:p="http://schemas.openxmlformats.org/presentationml/2006/main">
+  <p:cSld name="Slide 23">
+    <p:spTree>
+      <p:nvGrpSpPr>
+        <p:cNvPr id="1" name=""/>
+        <p:cNvGrpSpPr/>
+        <p:nvPr/>
+      </p:nvGrpSpPr>
+      <p:grpSpPr>
+        <a:xfrm>
+          <a:off x="0" y="0"/>
+          <a:ext cx="0" cy="0"/>
+          <a:chOff x="0" y="0"/>
+          <a:chExt cx="0" cy="0"/>
+        </a:xfrm>
+      </p:grpSpPr>
+      <p:sp>
+        <p:nvSpPr>
+          <p:cNvPr id="2" name="Text 0"/>
+          <p:cNvSpPr/>
+          <p:nvPr/>
+        </p:nvSpPr>
+        <p:spPr>
+          <a:xfrm>
+            <a:off x="502920" y="237744"/>
+            <a:ext cx="9601200" cy="292608"/>
+          </a:xfrm>
+          <a:prstGeom prst="rect">
+            <a:avLst/>
+          </a:prstGeom>
+          <a:noFill/>
+          <a:ln/>
+        </p:spPr>
+        <p:txBody>
+          <a:bodyPr wrap="square" lIns="0" tIns="0" rIns="0" bIns="0" rtlCol="0" anchor="ctr"/>
+          <a:lstStyle/>
+          <a:p>
+            <a:pPr indent="0" marL="0">
+              <a:buNone/>
+            </a:pPr>
+            <a:r>
+              <a:rPr lang="en-US" sz="1150" b="1" spc="100" kern="0" dirty="0">
+                <a:solidFill>
+                  <a:srgbClr val="1F77B4"/>
+                </a:solidFill>
+                <a:latin typeface="Arial" pitchFamily="34" charset="0"/>
+                <a:ea typeface="Arial" pitchFamily="34" charset="-122"/>
+                <a:cs typeface="Arial" pitchFamily="34" charset="-120"/>
+              </a:rPr>
               <a:t>APPENDIX A7</a:t>
             </a:r>
             <a:endParaRPr lang="en-US" sz="1150" dirty="0"/>
@@ -26520,14 +29347,41 @@
       </p:sp>
       <p:sp>
         <p:nvSpPr>
-          <p:cNvPr id="12" name="Text 9"/>
-          <p:cNvSpPr/>
-          <p:nvPr/>
-        </p:nvSpPr>
-        <p:spPr>
-          <a:xfrm>
-            <a:off x="502920" y="5029200"/>
-            <a:ext cx="11155680" cy="594360"/>
+          <p:cNvPr id="12" name="Shape 9"/>
+          <p:cNvSpPr/>
+          <p:nvPr/>
+        </p:nvSpPr>
+        <p:spPr>
+          <a:xfrm>
+            <a:off x="502920" y="4864608"/>
+            <a:ext cx="11201400" cy="1024128"/>
+          </a:xfrm>
+          <a:prstGeom prst="roundRect">
+            <a:avLst>
+              <a:gd name="adj" fmla="val 7143"/>
+            </a:avLst>
+          </a:prstGeom>
+          <a:solidFill>
+            <a:srgbClr val="EFF4F9"/>
+          </a:solidFill>
+          <a:ln w="12700">
+            <a:solidFill>
+              <a:srgbClr val="D5DEE8"/>
+            </a:solidFill>
+            <a:prstDash val="solid"/>
+          </a:ln>
+        </p:spPr>
+      </p:sp>
+      <p:sp>
+        <p:nvSpPr>
+          <p:cNvPr id="13" name="Text 10"/>
+          <p:cNvSpPr/>
+          <p:nvPr/>
+        </p:nvSpPr>
+        <p:spPr>
+          <a:xfrm>
+            <a:off x="777240" y="4974336"/>
+            <a:ext cx="10698480" cy="868680"/>
           </a:xfrm>
           <a:prstGeom prst="rect">
             <a:avLst/>
@@ -26540,26 +29394,49 @@
           <a:lstStyle/>
           <a:p>
             <a:pPr indent="0" marL="0">
+              <a:spcAft>
+                <a:spcPts val="500"/>
+              </a:spcAft>
               <a:buNone/>
             </a:pPr>
             <a:r>
-              <a:rPr lang="en-US" sz="1300" b="1" dirty="0">
-                <a:solidFill>
-                  <a:srgbClr val="1F77B4"/>
-                </a:solidFill>
-                <a:latin typeface="Arial" pitchFamily="34" charset="0"/>
-                <a:ea typeface="Arial" pitchFamily="34" charset="-122"/>
-                <a:cs typeface="Arial" pitchFamily="34" charset="-120"/>
-              </a:rPr>
-              <a:t>특히 — 차단한 결과(92.0%)가 이미지를 1장만 준 경우(89.3%)보다도 높았습니다: "얕게 차단하는 쪽이 더 싸면서 더 정확"</a:t>
-            </a:r>
-            <a:endParaRPr lang="en-US" sz="1300" dirty="0"/>
+              <a:rPr lang="en-US" sz="1250" b="1" dirty="0">
+                <a:solidFill>
+                  <a:srgbClr val="1F3B57"/>
+                </a:solidFill>
+                <a:latin typeface="Arial" pitchFamily="34" charset="0"/>
+                <a:ea typeface="Arial" pitchFamily="34" charset="-122"/>
+                <a:cs typeface="Arial" pitchFamily="34" charset="-120"/>
+              </a:rPr>
+              <a:t>"답을 '없다' 쪽으로 민 것 아닌가?" — 아닙니다. 오염이 있던 문항군만 오르고, 없던 대조군은 오르지 않았습니다.</a:t>
+            </a:r>
+            <a:endParaRPr lang="en-US" sz="1250" dirty="0"/>
+          </a:p>
+          <a:p>
+            <a:pPr indent="0" marL="0">
+              <a:spcAft>
+                <a:spcPts val="500"/>
+              </a:spcAft>
+              <a:buNone/>
+            </a:pPr>
+            <a:r>
+              <a:rPr lang="en-US" sz="1200" dirty="0">
+                <a:solidFill>
+                  <a:srgbClr val="6B7280"/>
+                </a:solidFill>
+                <a:latin typeface="Arial" pitchFamily="34" charset="0"/>
+                <a:ea typeface="Arial" pitchFamily="34" charset="-122"/>
+                <a:cs typeface="Arial" pitchFamily="34" charset="-120"/>
+              </a:rPr>
+              <a:t>오염 유발 문항군 72.0% → 92.0% (+20.0%p)   vs   같은 정답('없다')이지만 오염 없는 대조군 98.0% → 96.0% (−2.0%p)</a:t>
+            </a:r>
+            <a:endParaRPr lang="en-US" sz="1250" dirty="0"/>
           </a:p>
         </p:txBody>
       </p:sp>
       <p:sp>
         <p:nvSpPr>
-          <p:cNvPr id="13" name="Shape 10"/>
+          <p:cNvPr id="14" name="Shape 11"/>
           <p:cNvSpPr/>
           <p:nvPr/>
         </p:nvSpPr>
@@ -26581,7 +29458,7 @@
       </p:sp>
       <p:sp>
         <p:nvSpPr>
-          <p:cNvPr id="14" name="Text 11"/>
+          <p:cNvPr id="15" name="Text 12"/>
           <p:cNvSpPr/>
           <p:nvPr/>
         </p:nvSpPr>

</xml_diff>